<commit_message>
Add tanween decks (beginning/middle/end); new marimba/bell sound set for all decks
Co-Authored-By: Claude Sonnet 5.5 <noreply@anthropic.com>
Claude-Session: https://claude.ai/code/session_01FzFnzdoj1sJJKm8jQJSfJE
</commit_message>
<xml_diff>
--- a/all-letters-dammah/01-alif.pptx
+++ b/all-letters-dammah/01-alif.pptx
@@ -3169,7 +3169,7 @@
                                           </p:endCondLst>
                                         </p:cTn>
                                         <p:tgtEl>
-                                          <p:sndTgt r:embed="rIdSnd1" name="pop.wav"/>
+                                          <p:sndTgt r:embed="rIdSnd1" name="pluck1.wav"/>
                                         </p:tgtEl>
                                       </p:cMediaNode>
                                     </p:audio>
@@ -3241,7 +3241,7 @@
                                           </p:endCondLst>
                                         </p:cTn>
                                         <p:tgtEl>
-                                          <p:sndTgt r:embed="rIdSnd2" name="ding.wav"/>
+                                          <p:sndTgt r:embed="rIdSnd2" name="bell1.wav"/>
                                         </p:tgtEl>
                                       </p:cMediaNode>
                                     </p:audio>
@@ -4079,7 +4079,7 @@
                                           </p:endCondLst>
                                         </p:cTn>
                                         <p:tgtEl>
-                                          <p:sndTgt r:embed="rIdSnd1" name="pop.wav"/>
+                                          <p:sndTgt r:embed="rIdSnd1" name="pluck1.wav"/>
                                         </p:tgtEl>
                                       </p:cMediaNode>
                                     </p:audio>
@@ -4151,7 +4151,7 @@
                                           </p:endCondLst>
                                         </p:cTn>
                                         <p:tgtEl>
-                                          <p:sndTgt r:embed="rIdSnd2" name="ding.wav"/>
+                                          <p:sndTgt r:embed="rIdSnd2" name="bell1.wav"/>
                                         </p:tgtEl>
                                       </p:cMediaNode>
                                     </p:audio>
@@ -4223,7 +4223,7 @@
                                           </p:endCondLst>
                                         </p:cTn>
                                         <p:tgtEl>
-                                          <p:sndTgt r:embed="rIdSnd3" name="tick.wav"/>
+                                          <p:sndTgt r:embed="rIdSnd3" name="bloop.wav"/>
                                         </p:tgtEl>
                                       </p:cMediaNode>
                                     </p:audio>
@@ -4295,7 +4295,7 @@
                                           </p:endCondLst>
                                         </p:cTn>
                                         <p:tgtEl>
-                                          <p:sndTgt r:embed="rIdSnd1" name="pop.wav"/>
+                                          <p:sndTgt r:embed="rIdSnd4" name="pluck2.wav"/>
                                         </p:tgtEl>
                                       </p:cMediaNode>
                                     </p:audio>
@@ -4367,7 +4367,7 @@
                                           </p:endCondLst>
                                         </p:cTn>
                                         <p:tgtEl>
-                                          <p:sndTgt r:embed="rIdSnd2" name="ding.wav"/>
+                                          <p:sndTgt r:embed="rIdSnd5" name="bell2.wav"/>
                                         </p:tgtEl>
                                       </p:cMediaNode>
                                     </p:audio>
@@ -4439,7 +4439,7 @@
                                           </p:endCondLst>
                                         </p:cTn>
                                         <p:tgtEl>
-                                          <p:sndTgt r:embed="rIdSnd3" name="tick.wav"/>
+                                          <p:sndTgt r:embed="rIdSnd3" name="bloop.wav"/>
                                         </p:tgtEl>
                                       </p:cMediaNode>
                                     </p:audio>
@@ -4511,7 +4511,7 @@
                                           </p:endCondLst>
                                         </p:cTn>
                                         <p:tgtEl>
-                                          <p:sndTgt r:embed="rIdSnd1" name="pop.wav"/>
+                                          <p:sndTgt r:embed="rIdSnd6" name="pluck3.wav"/>
                                         </p:tgtEl>
                                       </p:cMediaNode>
                                     </p:audio>
@@ -4583,7 +4583,7 @@
                                           </p:endCondLst>
                                         </p:cTn>
                                         <p:tgtEl>
-                                          <p:sndTgt r:embed="rIdSnd2" name="ding.wav"/>
+                                          <p:sndTgt r:embed="rIdSnd7" name="bell3.wav"/>
                                         </p:tgtEl>
                                       </p:cMediaNode>
                                     </p:audio>
@@ -4655,7 +4655,7 @@
                                           </p:endCondLst>
                                         </p:cTn>
                                         <p:tgtEl>
-                                          <p:sndTgt r:embed="rIdSnd3" name="tick.wav"/>
+                                          <p:sndTgt r:embed="rIdSnd8" name="whoosh.wav"/>
                                         </p:tgtEl>
                                       </p:cMediaNode>
                                     </p:audio>
@@ -4727,7 +4727,7 @@
                                           </p:endCondLst>
                                         </p:cTn>
                                         <p:tgtEl>
-                                          <p:sndTgt r:embed="rIdSnd4" name="win.wav"/>
+                                          <p:sndTgt r:embed="rIdSnd9" name="win.wav"/>
                                         </p:tgtEl>
                                       </p:cMediaNode>
                                     </p:audio>
@@ -5573,7 +5573,7 @@
                                           </p:endCondLst>
                                         </p:cTn>
                                         <p:tgtEl>
-                                          <p:sndTgt r:embed="rIdSnd1" name="pop.wav"/>
+                                          <p:sndTgt r:embed="rIdSnd1" name="pluck1.wav"/>
                                         </p:tgtEl>
                                       </p:cMediaNode>
                                     </p:audio>
@@ -5645,7 +5645,7 @@
                                           </p:endCondLst>
                                         </p:cTn>
                                         <p:tgtEl>
-                                          <p:sndTgt r:embed="rIdSnd2" name="ding.wav"/>
+                                          <p:sndTgt r:embed="rIdSnd2" name="bell1.wav"/>
                                         </p:tgtEl>
                                       </p:cMediaNode>
                                     </p:audio>
@@ -5717,7 +5717,7 @@
                                           </p:endCondLst>
                                         </p:cTn>
                                         <p:tgtEl>
-                                          <p:sndTgt r:embed="rIdSnd3" name="tick.wav"/>
+                                          <p:sndTgt r:embed="rIdSnd3" name="bloop.wav"/>
                                         </p:tgtEl>
                                       </p:cMediaNode>
                                     </p:audio>
@@ -5789,7 +5789,7 @@
                                           </p:endCondLst>
                                         </p:cTn>
                                         <p:tgtEl>
-                                          <p:sndTgt r:embed="rIdSnd1" name="pop.wav"/>
+                                          <p:sndTgt r:embed="rIdSnd4" name="pluck2.wav"/>
                                         </p:tgtEl>
                                       </p:cMediaNode>
                                     </p:audio>
@@ -5861,7 +5861,7 @@
                                           </p:endCondLst>
                                         </p:cTn>
                                         <p:tgtEl>
-                                          <p:sndTgt r:embed="rIdSnd2" name="ding.wav"/>
+                                          <p:sndTgt r:embed="rIdSnd5" name="bell2.wav"/>
                                         </p:tgtEl>
                                       </p:cMediaNode>
                                     </p:audio>
@@ -5933,7 +5933,7 @@
                                           </p:endCondLst>
                                         </p:cTn>
                                         <p:tgtEl>
-                                          <p:sndTgt r:embed="rIdSnd3" name="tick.wav"/>
+                                          <p:sndTgt r:embed="rIdSnd3" name="bloop.wav"/>
                                         </p:tgtEl>
                                       </p:cMediaNode>
                                     </p:audio>
@@ -6005,7 +6005,7 @@
                                           </p:endCondLst>
                                         </p:cTn>
                                         <p:tgtEl>
-                                          <p:sndTgt r:embed="rIdSnd1" name="pop.wav"/>
+                                          <p:sndTgt r:embed="rIdSnd6" name="pluck3.wav"/>
                                         </p:tgtEl>
                                       </p:cMediaNode>
                                     </p:audio>
@@ -6077,7 +6077,7 @@
                                           </p:endCondLst>
                                         </p:cTn>
                                         <p:tgtEl>
-                                          <p:sndTgt r:embed="rIdSnd2" name="ding.wav"/>
+                                          <p:sndTgt r:embed="rIdSnd7" name="bell3.wav"/>
                                         </p:tgtEl>
                                       </p:cMediaNode>
                                     </p:audio>
@@ -6149,7 +6149,7 @@
                                           </p:endCondLst>
                                         </p:cTn>
                                         <p:tgtEl>
-                                          <p:sndTgt r:embed="rIdSnd3" name="tick.wav"/>
+                                          <p:sndTgt r:embed="rIdSnd8" name="whoosh.wav"/>
                                         </p:tgtEl>
                                       </p:cMediaNode>
                                     </p:audio>
@@ -6221,7 +6221,7 @@
                                           </p:endCondLst>
                                         </p:cTn>
                                         <p:tgtEl>
-                                          <p:sndTgt r:embed="rIdSnd4" name="win.wav"/>
+                                          <p:sndTgt r:embed="rIdSnd9" name="win.wav"/>
                                         </p:tgtEl>
                                       </p:cMediaNode>
                                     </p:audio>
@@ -7067,7 +7067,7 @@
                                           </p:endCondLst>
                                         </p:cTn>
                                         <p:tgtEl>
-                                          <p:sndTgt r:embed="rIdSnd1" name="pop.wav"/>
+                                          <p:sndTgt r:embed="rIdSnd1" name="pluck1.wav"/>
                                         </p:tgtEl>
                                       </p:cMediaNode>
                                     </p:audio>
@@ -7139,7 +7139,7 @@
                                           </p:endCondLst>
                                         </p:cTn>
                                         <p:tgtEl>
-                                          <p:sndTgt r:embed="rIdSnd2" name="ding.wav"/>
+                                          <p:sndTgt r:embed="rIdSnd2" name="bell1.wav"/>
                                         </p:tgtEl>
                                       </p:cMediaNode>
                                     </p:audio>
@@ -7211,7 +7211,7 @@
                                           </p:endCondLst>
                                         </p:cTn>
                                         <p:tgtEl>
-                                          <p:sndTgt r:embed="rIdSnd3" name="tick.wav"/>
+                                          <p:sndTgt r:embed="rIdSnd3" name="bloop.wav"/>
                                         </p:tgtEl>
                                       </p:cMediaNode>
                                     </p:audio>
@@ -7283,7 +7283,7 @@
                                           </p:endCondLst>
                                         </p:cTn>
                                         <p:tgtEl>
-                                          <p:sndTgt r:embed="rIdSnd1" name="pop.wav"/>
+                                          <p:sndTgt r:embed="rIdSnd4" name="pluck2.wav"/>
                                         </p:tgtEl>
                                       </p:cMediaNode>
                                     </p:audio>
@@ -7355,7 +7355,7 @@
                                           </p:endCondLst>
                                         </p:cTn>
                                         <p:tgtEl>
-                                          <p:sndTgt r:embed="rIdSnd2" name="ding.wav"/>
+                                          <p:sndTgt r:embed="rIdSnd5" name="bell2.wav"/>
                                         </p:tgtEl>
                                       </p:cMediaNode>
                                     </p:audio>
@@ -7427,7 +7427,7 @@
                                           </p:endCondLst>
                                         </p:cTn>
                                         <p:tgtEl>
-                                          <p:sndTgt r:embed="rIdSnd3" name="tick.wav"/>
+                                          <p:sndTgt r:embed="rIdSnd3" name="bloop.wav"/>
                                         </p:tgtEl>
                                       </p:cMediaNode>
                                     </p:audio>
@@ -7499,7 +7499,7 @@
                                           </p:endCondLst>
                                         </p:cTn>
                                         <p:tgtEl>
-                                          <p:sndTgt r:embed="rIdSnd1" name="pop.wav"/>
+                                          <p:sndTgt r:embed="rIdSnd6" name="pluck3.wav"/>
                                         </p:tgtEl>
                                       </p:cMediaNode>
                                     </p:audio>
@@ -7571,7 +7571,7 @@
                                           </p:endCondLst>
                                         </p:cTn>
                                         <p:tgtEl>
-                                          <p:sndTgt r:embed="rIdSnd2" name="ding.wav"/>
+                                          <p:sndTgt r:embed="rIdSnd7" name="bell3.wav"/>
                                         </p:tgtEl>
                                       </p:cMediaNode>
                                     </p:audio>
@@ -7643,7 +7643,7 @@
                                           </p:endCondLst>
                                         </p:cTn>
                                         <p:tgtEl>
-                                          <p:sndTgt r:embed="rIdSnd3" name="tick.wav"/>
+                                          <p:sndTgt r:embed="rIdSnd8" name="whoosh.wav"/>
                                         </p:tgtEl>
                                       </p:cMediaNode>
                                     </p:audio>
@@ -7715,7 +7715,7 @@
                                           </p:endCondLst>
                                         </p:cTn>
                                         <p:tgtEl>
-                                          <p:sndTgt r:embed="rIdSnd4" name="win.wav"/>
+                                          <p:sndTgt r:embed="rIdSnd9" name="win.wav"/>
                                         </p:tgtEl>
                                       </p:cMediaNode>
                                     </p:audio>
@@ -8561,7 +8561,7 @@
                                           </p:endCondLst>
                                         </p:cTn>
                                         <p:tgtEl>
-                                          <p:sndTgt r:embed="rIdSnd1" name="pop.wav"/>
+                                          <p:sndTgt r:embed="rIdSnd1" name="pluck1.wav"/>
                                         </p:tgtEl>
                                       </p:cMediaNode>
                                     </p:audio>
@@ -8633,7 +8633,7 @@
                                           </p:endCondLst>
                                         </p:cTn>
                                         <p:tgtEl>
-                                          <p:sndTgt r:embed="rIdSnd2" name="ding.wav"/>
+                                          <p:sndTgt r:embed="rIdSnd2" name="bell1.wav"/>
                                         </p:tgtEl>
                                       </p:cMediaNode>
                                     </p:audio>
@@ -8705,7 +8705,7 @@
                                           </p:endCondLst>
                                         </p:cTn>
                                         <p:tgtEl>
-                                          <p:sndTgt r:embed="rIdSnd3" name="tick.wav"/>
+                                          <p:sndTgt r:embed="rIdSnd3" name="bloop.wav"/>
                                         </p:tgtEl>
                                       </p:cMediaNode>
                                     </p:audio>
@@ -8777,7 +8777,7 @@
                                           </p:endCondLst>
                                         </p:cTn>
                                         <p:tgtEl>
-                                          <p:sndTgt r:embed="rIdSnd1" name="pop.wav"/>
+                                          <p:sndTgt r:embed="rIdSnd4" name="pluck2.wav"/>
                                         </p:tgtEl>
                                       </p:cMediaNode>
                                     </p:audio>
@@ -8849,7 +8849,7 @@
                                           </p:endCondLst>
                                         </p:cTn>
                                         <p:tgtEl>
-                                          <p:sndTgt r:embed="rIdSnd2" name="ding.wav"/>
+                                          <p:sndTgt r:embed="rIdSnd5" name="bell2.wav"/>
                                         </p:tgtEl>
                                       </p:cMediaNode>
                                     </p:audio>
@@ -8921,7 +8921,7 @@
                                           </p:endCondLst>
                                         </p:cTn>
                                         <p:tgtEl>
-                                          <p:sndTgt r:embed="rIdSnd3" name="tick.wav"/>
+                                          <p:sndTgt r:embed="rIdSnd3" name="bloop.wav"/>
                                         </p:tgtEl>
                                       </p:cMediaNode>
                                     </p:audio>
@@ -8993,7 +8993,7 @@
                                           </p:endCondLst>
                                         </p:cTn>
                                         <p:tgtEl>
-                                          <p:sndTgt r:embed="rIdSnd1" name="pop.wav"/>
+                                          <p:sndTgt r:embed="rIdSnd6" name="pluck3.wav"/>
                                         </p:tgtEl>
                                       </p:cMediaNode>
                                     </p:audio>
@@ -9065,7 +9065,7 @@
                                           </p:endCondLst>
                                         </p:cTn>
                                         <p:tgtEl>
-                                          <p:sndTgt r:embed="rIdSnd2" name="ding.wav"/>
+                                          <p:sndTgt r:embed="rIdSnd7" name="bell3.wav"/>
                                         </p:tgtEl>
                                       </p:cMediaNode>
                                     </p:audio>
@@ -9137,7 +9137,7 @@
                                           </p:endCondLst>
                                         </p:cTn>
                                         <p:tgtEl>
-                                          <p:sndTgt r:embed="rIdSnd3" name="tick.wav"/>
+                                          <p:sndTgt r:embed="rIdSnd8" name="whoosh.wav"/>
                                         </p:tgtEl>
                                       </p:cMediaNode>
                                     </p:audio>
@@ -9209,7 +9209,7 @@
                                           </p:endCondLst>
                                         </p:cTn>
                                         <p:tgtEl>
-                                          <p:sndTgt r:embed="rIdSnd4" name="win.wav"/>
+                                          <p:sndTgt r:embed="rIdSnd9" name="win.wav"/>
                                         </p:tgtEl>
                                       </p:cMediaNode>
                                     </p:audio>
@@ -10055,7 +10055,7 @@
                                           </p:endCondLst>
                                         </p:cTn>
                                         <p:tgtEl>
-                                          <p:sndTgt r:embed="rIdSnd1" name="pop.wav"/>
+                                          <p:sndTgt r:embed="rIdSnd1" name="pluck1.wav"/>
                                         </p:tgtEl>
                                       </p:cMediaNode>
                                     </p:audio>
@@ -10127,7 +10127,7 @@
                                           </p:endCondLst>
                                         </p:cTn>
                                         <p:tgtEl>
-                                          <p:sndTgt r:embed="rIdSnd2" name="ding.wav"/>
+                                          <p:sndTgt r:embed="rIdSnd2" name="bell1.wav"/>
                                         </p:tgtEl>
                                       </p:cMediaNode>
                                     </p:audio>
@@ -10199,7 +10199,7 @@
                                           </p:endCondLst>
                                         </p:cTn>
                                         <p:tgtEl>
-                                          <p:sndTgt r:embed="rIdSnd3" name="tick.wav"/>
+                                          <p:sndTgt r:embed="rIdSnd3" name="bloop.wav"/>
                                         </p:tgtEl>
                                       </p:cMediaNode>
                                     </p:audio>
@@ -10271,7 +10271,7 @@
                                           </p:endCondLst>
                                         </p:cTn>
                                         <p:tgtEl>
-                                          <p:sndTgt r:embed="rIdSnd1" name="pop.wav"/>
+                                          <p:sndTgt r:embed="rIdSnd4" name="pluck2.wav"/>
                                         </p:tgtEl>
                                       </p:cMediaNode>
                                     </p:audio>
@@ -10343,7 +10343,7 @@
                                           </p:endCondLst>
                                         </p:cTn>
                                         <p:tgtEl>
-                                          <p:sndTgt r:embed="rIdSnd2" name="ding.wav"/>
+                                          <p:sndTgt r:embed="rIdSnd5" name="bell2.wav"/>
                                         </p:tgtEl>
                                       </p:cMediaNode>
                                     </p:audio>
@@ -10415,7 +10415,7 @@
                                           </p:endCondLst>
                                         </p:cTn>
                                         <p:tgtEl>
-                                          <p:sndTgt r:embed="rIdSnd3" name="tick.wav"/>
+                                          <p:sndTgt r:embed="rIdSnd3" name="bloop.wav"/>
                                         </p:tgtEl>
                                       </p:cMediaNode>
                                     </p:audio>
@@ -10487,7 +10487,7 @@
                                           </p:endCondLst>
                                         </p:cTn>
                                         <p:tgtEl>
-                                          <p:sndTgt r:embed="rIdSnd1" name="pop.wav"/>
+                                          <p:sndTgt r:embed="rIdSnd6" name="pluck3.wav"/>
                                         </p:tgtEl>
                                       </p:cMediaNode>
                                     </p:audio>
@@ -10559,7 +10559,7 @@
                                           </p:endCondLst>
                                         </p:cTn>
                                         <p:tgtEl>
-                                          <p:sndTgt r:embed="rIdSnd2" name="ding.wav"/>
+                                          <p:sndTgt r:embed="rIdSnd7" name="bell3.wav"/>
                                         </p:tgtEl>
                                       </p:cMediaNode>
                                     </p:audio>
@@ -10631,7 +10631,7 @@
                                           </p:endCondLst>
                                         </p:cTn>
                                         <p:tgtEl>
-                                          <p:sndTgt r:embed="rIdSnd3" name="tick.wav"/>
+                                          <p:sndTgt r:embed="rIdSnd8" name="whoosh.wav"/>
                                         </p:tgtEl>
                                       </p:cMediaNode>
                                     </p:audio>
@@ -10703,7 +10703,7 @@
                                           </p:endCondLst>
                                         </p:cTn>
                                         <p:tgtEl>
-                                          <p:sndTgt r:embed="rIdSnd4" name="win.wav"/>
+                                          <p:sndTgt r:embed="rIdSnd9" name="win.wav"/>
                                         </p:tgtEl>
                                       </p:cMediaNode>
                                     </p:audio>
@@ -11549,7 +11549,7 @@
                                           </p:endCondLst>
                                         </p:cTn>
                                         <p:tgtEl>
-                                          <p:sndTgt r:embed="rIdSnd1" name="pop.wav"/>
+                                          <p:sndTgt r:embed="rIdSnd1" name="pluck1.wav"/>
                                         </p:tgtEl>
                                       </p:cMediaNode>
                                     </p:audio>
@@ -11621,7 +11621,7 @@
                                           </p:endCondLst>
                                         </p:cTn>
                                         <p:tgtEl>
-                                          <p:sndTgt r:embed="rIdSnd2" name="ding.wav"/>
+                                          <p:sndTgt r:embed="rIdSnd2" name="bell1.wav"/>
                                         </p:tgtEl>
                                       </p:cMediaNode>
                                     </p:audio>
@@ -11693,7 +11693,7 @@
                                           </p:endCondLst>
                                         </p:cTn>
                                         <p:tgtEl>
-                                          <p:sndTgt r:embed="rIdSnd3" name="tick.wav"/>
+                                          <p:sndTgt r:embed="rIdSnd3" name="bloop.wav"/>
                                         </p:tgtEl>
                                       </p:cMediaNode>
                                     </p:audio>
@@ -11765,7 +11765,7 @@
                                           </p:endCondLst>
                                         </p:cTn>
                                         <p:tgtEl>
-                                          <p:sndTgt r:embed="rIdSnd1" name="pop.wav"/>
+                                          <p:sndTgt r:embed="rIdSnd4" name="pluck2.wav"/>
                                         </p:tgtEl>
                                       </p:cMediaNode>
                                     </p:audio>
@@ -11837,7 +11837,7 @@
                                           </p:endCondLst>
                                         </p:cTn>
                                         <p:tgtEl>
-                                          <p:sndTgt r:embed="rIdSnd2" name="ding.wav"/>
+                                          <p:sndTgt r:embed="rIdSnd5" name="bell2.wav"/>
                                         </p:tgtEl>
                                       </p:cMediaNode>
                                     </p:audio>
@@ -11909,7 +11909,7 @@
                                           </p:endCondLst>
                                         </p:cTn>
                                         <p:tgtEl>
-                                          <p:sndTgt r:embed="rIdSnd3" name="tick.wav"/>
+                                          <p:sndTgt r:embed="rIdSnd3" name="bloop.wav"/>
                                         </p:tgtEl>
                                       </p:cMediaNode>
                                     </p:audio>
@@ -11981,7 +11981,7 @@
                                           </p:endCondLst>
                                         </p:cTn>
                                         <p:tgtEl>
-                                          <p:sndTgt r:embed="rIdSnd1" name="pop.wav"/>
+                                          <p:sndTgt r:embed="rIdSnd6" name="pluck3.wav"/>
                                         </p:tgtEl>
                                       </p:cMediaNode>
                                     </p:audio>
@@ -12053,7 +12053,7 @@
                                           </p:endCondLst>
                                         </p:cTn>
                                         <p:tgtEl>
-                                          <p:sndTgt r:embed="rIdSnd2" name="ding.wav"/>
+                                          <p:sndTgt r:embed="rIdSnd7" name="bell3.wav"/>
                                         </p:tgtEl>
                                       </p:cMediaNode>
                                     </p:audio>
@@ -12125,7 +12125,7 @@
                                           </p:endCondLst>
                                         </p:cTn>
                                         <p:tgtEl>
-                                          <p:sndTgt r:embed="rIdSnd3" name="tick.wav"/>
+                                          <p:sndTgt r:embed="rIdSnd8" name="whoosh.wav"/>
                                         </p:tgtEl>
                                       </p:cMediaNode>
                                     </p:audio>
@@ -12197,7 +12197,7 @@
                                           </p:endCondLst>
                                         </p:cTn>
                                         <p:tgtEl>
-                                          <p:sndTgt r:embed="rIdSnd4" name="win.wav"/>
+                                          <p:sndTgt r:embed="rIdSnd9" name="win.wav"/>
                                         </p:tgtEl>
                                       </p:cMediaNode>
                                     </p:audio>
@@ -12915,7 +12915,7 @@
                                           </p:endCondLst>
                                         </p:cTn>
                                         <p:tgtEl>
-                                          <p:sndTgt r:embed="rIdSnd1" name="pop.wav"/>
+                                          <p:sndTgt r:embed="rIdSnd1" name="pluck1.wav"/>
                                         </p:tgtEl>
                                       </p:cMediaNode>
                                     </p:audio>
@@ -12987,7 +12987,7 @@
                                           </p:endCondLst>
                                         </p:cTn>
                                         <p:tgtEl>
-                                          <p:sndTgt r:embed="rIdSnd2" name="ding.wav"/>
+                                          <p:sndTgt r:embed="rIdSnd2" name="bell1.wav"/>
                                         </p:tgtEl>
                                       </p:cMediaNode>
                                     </p:audio>
@@ -13059,7 +13059,7 @@
                                           </p:endCondLst>
                                         </p:cTn>
                                         <p:tgtEl>
-                                          <p:sndTgt r:embed="rIdSnd3" name="tick.wav"/>
+                                          <p:sndTgt r:embed="rIdSnd3" name="bloop.wav"/>
                                         </p:tgtEl>
                                       </p:cMediaNode>
                                     </p:audio>
@@ -13131,7 +13131,7 @@
                                           </p:endCondLst>
                                         </p:cTn>
                                         <p:tgtEl>
-                                          <p:sndTgt r:embed="rIdSnd1" name="pop.wav"/>
+                                          <p:sndTgt r:embed="rIdSnd4" name="pluck2.wav"/>
                                         </p:tgtEl>
                                       </p:cMediaNode>
                                     </p:audio>
@@ -13203,7 +13203,7 @@
                                           </p:endCondLst>
                                         </p:cTn>
                                         <p:tgtEl>
-                                          <p:sndTgt r:embed="rIdSnd2" name="ding.wav"/>
+                                          <p:sndTgt r:embed="rIdSnd5" name="bell2.wav"/>
                                         </p:tgtEl>
                                       </p:cMediaNode>
                                     </p:audio>
@@ -13275,7 +13275,7 @@
                                           </p:endCondLst>
                                         </p:cTn>
                                         <p:tgtEl>
-                                          <p:sndTgt r:embed="rIdSnd3" name="tick.wav"/>
+                                          <p:sndTgt r:embed="rIdSnd6" name="whoosh.wav"/>
                                         </p:tgtEl>
                                       </p:cMediaNode>
                                     </p:audio>
@@ -13347,7 +13347,7 @@
                                           </p:endCondLst>
                                         </p:cTn>
                                         <p:tgtEl>
-                                          <p:sndTgt r:embed="rIdSnd4" name="win.wav"/>
+                                          <p:sndTgt r:embed="rIdSnd7" name="win.wav"/>
                                         </p:tgtEl>
                                       </p:cMediaNode>
                                     </p:audio>
@@ -14062,7 +14062,7 @@
                                           </p:endCondLst>
                                         </p:cTn>
                                         <p:tgtEl>
-                                          <p:sndTgt r:embed="rIdSnd1" name="pop.wav"/>
+                                          <p:sndTgt r:embed="rIdSnd1" name="pluck1.wav"/>
                                         </p:tgtEl>
                                       </p:cMediaNode>
                                     </p:audio>
@@ -14134,7 +14134,7 @@
                                           </p:endCondLst>
                                         </p:cTn>
                                         <p:tgtEl>
-                                          <p:sndTgt r:embed="rIdSnd2" name="ding.wav"/>
+                                          <p:sndTgt r:embed="rIdSnd2" name="bell1.wav"/>
                                         </p:tgtEl>
                                       </p:cMediaNode>
                                     </p:audio>
@@ -14206,7 +14206,7 @@
                                           </p:endCondLst>
                                         </p:cTn>
                                         <p:tgtEl>
-                                          <p:sndTgt r:embed="rIdSnd3" name="tick.wav"/>
+                                          <p:sndTgt r:embed="rIdSnd3" name="bloop.wav"/>
                                         </p:tgtEl>
                                       </p:cMediaNode>
                                     </p:audio>
@@ -14278,7 +14278,7 @@
                                           </p:endCondLst>
                                         </p:cTn>
                                         <p:tgtEl>
-                                          <p:sndTgt r:embed="rIdSnd1" name="pop.wav"/>
+                                          <p:sndTgt r:embed="rIdSnd4" name="pluck2.wav"/>
                                         </p:tgtEl>
                                       </p:cMediaNode>
                                     </p:audio>
@@ -14350,7 +14350,7 @@
                                           </p:endCondLst>
                                         </p:cTn>
                                         <p:tgtEl>
-                                          <p:sndTgt r:embed="rIdSnd2" name="ding.wav"/>
+                                          <p:sndTgt r:embed="rIdSnd5" name="bell2.wav"/>
                                         </p:tgtEl>
                                       </p:cMediaNode>
                                     </p:audio>
@@ -14422,7 +14422,7 @@
                                           </p:endCondLst>
                                         </p:cTn>
                                         <p:tgtEl>
-                                          <p:sndTgt r:embed="rIdSnd3" name="tick.wav"/>
+                                          <p:sndTgt r:embed="rIdSnd6" name="whoosh.wav"/>
                                         </p:tgtEl>
                                       </p:cMediaNode>
                                     </p:audio>
@@ -14494,7 +14494,7 @@
                                           </p:endCondLst>
                                         </p:cTn>
                                         <p:tgtEl>
-                                          <p:sndTgt r:embed="rIdSnd4" name="win.wav"/>
+                                          <p:sndTgt r:embed="rIdSnd7" name="win.wav"/>
                                         </p:tgtEl>
                                       </p:cMediaNode>
                                     </p:audio>
@@ -15209,7 +15209,7 @@
                                           </p:endCondLst>
                                         </p:cTn>
                                         <p:tgtEl>
-                                          <p:sndTgt r:embed="rIdSnd1" name="pop.wav"/>
+                                          <p:sndTgt r:embed="rIdSnd1" name="pluck1.wav"/>
                                         </p:tgtEl>
                                       </p:cMediaNode>
                                     </p:audio>
@@ -15281,7 +15281,7 @@
                                           </p:endCondLst>
                                         </p:cTn>
                                         <p:tgtEl>
-                                          <p:sndTgt r:embed="rIdSnd2" name="ding.wav"/>
+                                          <p:sndTgt r:embed="rIdSnd2" name="bell1.wav"/>
                                         </p:tgtEl>
                                       </p:cMediaNode>
                                     </p:audio>
@@ -15353,7 +15353,7 @@
                                           </p:endCondLst>
                                         </p:cTn>
                                         <p:tgtEl>
-                                          <p:sndTgt r:embed="rIdSnd3" name="tick.wav"/>
+                                          <p:sndTgt r:embed="rIdSnd3" name="bloop.wav"/>
                                         </p:tgtEl>
                                       </p:cMediaNode>
                                     </p:audio>
@@ -15425,7 +15425,7 @@
                                           </p:endCondLst>
                                         </p:cTn>
                                         <p:tgtEl>
-                                          <p:sndTgt r:embed="rIdSnd1" name="pop.wav"/>
+                                          <p:sndTgt r:embed="rIdSnd4" name="pluck2.wav"/>
                                         </p:tgtEl>
                                       </p:cMediaNode>
                                     </p:audio>
@@ -15497,7 +15497,7 @@
                                           </p:endCondLst>
                                         </p:cTn>
                                         <p:tgtEl>
-                                          <p:sndTgt r:embed="rIdSnd2" name="ding.wav"/>
+                                          <p:sndTgt r:embed="rIdSnd5" name="bell2.wav"/>
                                         </p:tgtEl>
                                       </p:cMediaNode>
                                     </p:audio>
@@ -15569,7 +15569,7 @@
                                           </p:endCondLst>
                                         </p:cTn>
                                         <p:tgtEl>
-                                          <p:sndTgt r:embed="rIdSnd3" name="tick.wav"/>
+                                          <p:sndTgt r:embed="rIdSnd6" name="whoosh.wav"/>
                                         </p:tgtEl>
                                       </p:cMediaNode>
                                     </p:audio>
@@ -15641,7 +15641,7 @@
                                           </p:endCondLst>
                                         </p:cTn>
                                         <p:tgtEl>
-                                          <p:sndTgt r:embed="rIdSnd4" name="win.wav"/>
+                                          <p:sndTgt r:embed="rIdSnd7" name="win.wav"/>
                                         </p:tgtEl>
                                       </p:cMediaNode>
                                     </p:audio>
@@ -16356,7 +16356,7 @@
                                           </p:endCondLst>
                                         </p:cTn>
                                         <p:tgtEl>
-                                          <p:sndTgt r:embed="rIdSnd1" name="pop.wav"/>
+                                          <p:sndTgt r:embed="rIdSnd1" name="pluck1.wav"/>
                                         </p:tgtEl>
                                       </p:cMediaNode>
                                     </p:audio>
@@ -16428,7 +16428,7 @@
                                           </p:endCondLst>
                                         </p:cTn>
                                         <p:tgtEl>
-                                          <p:sndTgt r:embed="rIdSnd2" name="ding.wav"/>
+                                          <p:sndTgt r:embed="rIdSnd2" name="bell1.wav"/>
                                         </p:tgtEl>
                                       </p:cMediaNode>
                                     </p:audio>
@@ -16500,7 +16500,7 @@
                                           </p:endCondLst>
                                         </p:cTn>
                                         <p:tgtEl>
-                                          <p:sndTgt r:embed="rIdSnd3" name="tick.wav"/>
+                                          <p:sndTgt r:embed="rIdSnd3" name="bloop.wav"/>
                                         </p:tgtEl>
                                       </p:cMediaNode>
                                     </p:audio>
@@ -16572,7 +16572,7 @@
                                           </p:endCondLst>
                                         </p:cTn>
                                         <p:tgtEl>
-                                          <p:sndTgt r:embed="rIdSnd1" name="pop.wav"/>
+                                          <p:sndTgt r:embed="rIdSnd4" name="pluck2.wav"/>
                                         </p:tgtEl>
                                       </p:cMediaNode>
                                     </p:audio>
@@ -16644,7 +16644,7 @@
                                           </p:endCondLst>
                                         </p:cTn>
                                         <p:tgtEl>
-                                          <p:sndTgt r:embed="rIdSnd2" name="ding.wav"/>
+                                          <p:sndTgt r:embed="rIdSnd5" name="bell2.wav"/>
                                         </p:tgtEl>
                                       </p:cMediaNode>
                                     </p:audio>
@@ -16716,7 +16716,7 @@
                                           </p:endCondLst>
                                         </p:cTn>
                                         <p:tgtEl>
-                                          <p:sndTgt r:embed="rIdSnd3" name="tick.wav"/>
+                                          <p:sndTgt r:embed="rIdSnd6" name="whoosh.wav"/>
                                         </p:tgtEl>
                                       </p:cMediaNode>
                                     </p:audio>
@@ -16788,7 +16788,7 @@
                                           </p:endCondLst>
                                         </p:cTn>
                                         <p:tgtEl>
-                                          <p:sndTgt r:embed="rIdSnd4" name="win.wav"/>
+                                          <p:sndTgt r:embed="rIdSnd7" name="win.wav"/>
                                         </p:tgtEl>
                                       </p:cMediaNode>
                                     </p:audio>
@@ -17503,7 +17503,7 @@
                                           </p:endCondLst>
                                         </p:cTn>
                                         <p:tgtEl>
-                                          <p:sndTgt r:embed="rIdSnd1" name="pop.wav"/>
+                                          <p:sndTgt r:embed="rIdSnd1" name="pluck1.wav"/>
                                         </p:tgtEl>
                                       </p:cMediaNode>
                                     </p:audio>
@@ -17575,7 +17575,7 @@
                                           </p:endCondLst>
                                         </p:cTn>
                                         <p:tgtEl>
-                                          <p:sndTgt r:embed="rIdSnd2" name="ding.wav"/>
+                                          <p:sndTgt r:embed="rIdSnd2" name="bell1.wav"/>
                                         </p:tgtEl>
                                       </p:cMediaNode>
                                     </p:audio>
@@ -17647,7 +17647,7 @@
                                           </p:endCondLst>
                                         </p:cTn>
                                         <p:tgtEl>
-                                          <p:sndTgt r:embed="rIdSnd3" name="tick.wav"/>
+                                          <p:sndTgt r:embed="rIdSnd3" name="bloop.wav"/>
                                         </p:tgtEl>
                                       </p:cMediaNode>
                                     </p:audio>
@@ -17719,7 +17719,7 @@
                                           </p:endCondLst>
                                         </p:cTn>
                                         <p:tgtEl>
-                                          <p:sndTgt r:embed="rIdSnd1" name="pop.wav"/>
+                                          <p:sndTgt r:embed="rIdSnd4" name="pluck2.wav"/>
                                         </p:tgtEl>
                                       </p:cMediaNode>
                                     </p:audio>
@@ -17791,7 +17791,7 @@
                                           </p:endCondLst>
                                         </p:cTn>
                                         <p:tgtEl>
-                                          <p:sndTgt r:embed="rIdSnd2" name="ding.wav"/>
+                                          <p:sndTgt r:embed="rIdSnd5" name="bell2.wav"/>
                                         </p:tgtEl>
                                       </p:cMediaNode>
                                     </p:audio>
@@ -17863,7 +17863,7 @@
                                           </p:endCondLst>
                                         </p:cTn>
                                         <p:tgtEl>
-                                          <p:sndTgt r:embed="rIdSnd3" name="tick.wav"/>
+                                          <p:sndTgt r:embed="rIdSnd6" name="whoosh.wav"/>
                                         </p:tgtEl>
                                       </p:cMediaNode>
                                     </p:audio>
@@ -17935,7 +17935,7 @@
                                           </p:endCondLst>
                                         </p:cTn>
                                         <p:tgtEl>
-                                          <p:sndTgt r:embed="rIdSnd4" name="win.wav"/>
+                                          <p:sndTgt r:embed="rIdSnd7" name="win.wav"/>
                                         </p:tgtEl>
                                       </p:cMediaNode>
                                     </p:audio>
@@ -18650,7 +18650,7 @@
                                           </p:endCondLst>
                                         </p:cTn>
                                         <p:tgtEl>
-                                          <p:sndTgt r:embed="rIdSnd1" name="pop.wav"/>
+                                          <p:sndTgt r:embed="rIdSnd1" name="pluck1.wav"/>
                                         </p:tgtEl>
                                       </p:cMediaNode>
                                     </p:audio>
@@ -18722,7 +18722,7 @@
                                           </p:endCondLst>
                                         </p:cTn>
                                         <p:tgtEl>
-                                          <p:sndTgt r:embed="rIdSnd2" name="ding.wav"/>
+                                          <p:sndTgt r:embed="rIdSnd2" name="bell1.wav"/>
                                         </p:tgtEl>
                                       </p:cMediaNode>
                                     </p:audio>
@@ -18794,7 +18794,7 @@
                                           </p:endCondLst>
                                         </p:cTn>
                                         <p:tgtEl>
-                                          <p:sndTgt r:embed="rIdSnd3" name="tick.wav"/>
+                                          <p:sndTgt r:embed="rIdSnd3" name="bloop.wav"/>
                                         </p:tgtEl>
                                       </p:cMediaNode>
                                     </p:audio>
@@ -18866,7 +18866,7 @@
                                           </p:endCondLst>
                                         </p:cTn>
                                         <p:tgtEl>
-                                          <p:sndTgt r:embed="rIdSnd1" name="pop.wav"/>
+                                          <p:sndTgt r:embed="rIdSnd4" name="pluck2.wav"/>
                                         </p:tgtEl>
                                       </p:cMediaNode>
                                     </p:audio>
@@ -18938,7 +18938,7 @@
                                           </p:endCondLst>
                                         </p:cTn>
                                         <p:tgtEl>
-                                          <p:sndTgt r:embed="rIdSnd2" name="ding.wav"/>
+                                          <p:sndTgt r:embed="rIdSnd5" name="bell2.wav"/>
                                         </p:tgtEl>
                                       </p:cMediaNode>
                                     </p:audio>
@@ -19010,7 +19010,7 @@
                                           </p:endCondLst>
                                         </p:cTn>
                                         <p:tgtEl>
-                                          <p:sndTgt r:embed="rIdSnd3" name="tick.wav"/>
+                                          <p:sndTgt r:embed="rIdSnd6" name="whoosh.wav"/>
                                         </p:tgtEl>
                                       </p:cMediaNode>
                                     </p:audio>
@@ -19082,7 +19082,7 @@
                                           </p:endCondLst>
                                         </p:cTn>
                                         <p:tgtEl>
-                                          <p:sndTgt r:embed="rIdSnd4" name="win.wav"/>
+                                          <p:sndTgt r:embed="rIdSnd7" name="win.wav"/>
                                         </p:tgtEl>
                                       </p:cMediaNode>
                                     </p:audio>
@@ -19797,7 +19797,7 @@
                                           </p:endCondLst>
                                         </p:cTn>
                                         <p:tgtEl>
-                                          <p:sndTgt r:embed="rIdSnd1" name="pop.wav"/>
+                                          <p:sndTgt r:embed="rIdSnd1" name="pluck1.wav"/>
                                         </p:tgtEl>
                                       </p:cMediaNode>
                                     </p:audio>
@@ -19869,7 +19869,7 @@
                                           </p:endCondLst>
                                         </p:cTn>
                                         <p:tgtEl>
-                                          <p:sndTgt r:embed="rIdSnd2" name="ding.wav"/>
+                                          <p:sndTgt r:embed="rIdSnd2" name="bell1.wav"/>
                                         </p:tgtEl>
                                       </p:cMediaNode>
                                     </p:audio>
@@ -19941,7 +19941,7 @@
                                           </p:endCondLst>
                                         </p:cTn>
                                         <p:tgtEl>
-                                          <p:sndTgt r:embed="rIdSnd3" name="tick.wav"/>
+                                          <p:sndTgt r:embed="rIdSnd3" name="bloop.wav"/>
                                         </p:tgtEl>
                                       </p:cMediaNode>
                                     </p:audio>
@@ -20013,7 +20013,7 @@
                                           </p:endCondLst>
                                         </p:cTn>
                                         <p:tgtEl>
-                                          <p:sndTgt r:embed="rIdSnd1" name="pop.wav"/>
+                                          <p:sndTgt r:embed="rIdSnd4" name="pluck2.wav"/>
                                         </p:tgtEl>
                                       </p:cMediaNode>
                                     </p:audio>
@@ -20085,7 +20085,7 @@
                                           </p:endCondLst>
                                         </p:cTn>
                                         <p:tgtEl>
-                                          <p:sndTgt r:embed="rIdSnd2" name="ding.wav"/>
+                                          <p:sndTgt r:embed="rIdSnd5" name="bell2.wav"/>
                                         </p:tgtEl>
                                       </p:cMediaNode>
                                     </p:audio>
@@ -20157,7 +20157,7 @@
                                           </p:endCondLst>
                                         </p:cTn>
                                         <p:tgtEl>
-                                          <p:sndTgt r:embed="rIdSnd3" name="tick.wav"/>
+                                          <p:sndTgt r:embed="rIdSnd6" name="whoosh.wav"/>
                                         </p:tgtEl>
                                       </p:cMediaNode>
                                     </p:audio>
@@ -20229,7 +20229,7 @@
                                           </p:endCondLst>
                                         </p:cTn>
                                         <p:tgtEl>
-                                          <p:sndTgt r:embed="rIdSnd4" name="win.wav"/>
+                                          <p:sndTgt r:embed="rIdSnd7" name="win.wav"/>
                                         </p:tgtEl>
                                       </p:cMediaNode>
                                     </p:audio>
@@ -20944,7 +20944,7 @@
                                           </p:endCondLst>
                                         </p:cTn>
                                         <p:tgtEl>
-                                          <p:sndTgt r:embed="rIdSnd1" name="pop.wav"/>
+                                          <p:sndTgt r:embed="rIdSnd1" name="pluck1.wav"/>
                                         </p:tgtEl>
                                       </p:cMediaNode>
                                     </p:audio>
@@ -21016,7 +21016,7 @@
                                           </p:endCondLst>
                                         </p:cTn>
                                         <p:tgtEl>
-                                          <p:sndTgt r:embed="rIdSnd2" name="ding.wav"/>
+                                          <p:sndTgt r:embed="rIdSnd2" name="bell1.wav"/>
                                         </p:tgtEl>
                                       </p:cMediaNode>
                                     </p:audio>
@@ -21088,7 +21088,7 @@
                                           </p:endCondLst>
                                         </p:cTn>
                                         <p:tgtEl>
-                                          <p:sndTgt r:embed="rIdSnd3" name="tick.wav"/>
+                                          <p:sndTgt r:embed="rIdSnd3" name="bloop.wav"/>
                                         </p:tgtEl>
                                       </p:cMediaNode>
                                     </p:audio>
@@ -21160,7 +21160,7 @@
                                           </p:endCondLst>
                                         </p:cTn>
                                         <p:tgtEl>
-                                          <p:sndTgt r:embed="rIdSnd1" name="pop.wav"/>
+                                          <p:sndTgt r:embed="rIdSnd4" name="pluck2.wav"/>
                                         </p:tgtEl>
                                       </p:cMediaNode>
                                     </p:audio>
@@ -21232,7 +21232,7 @@
                                           </p:endCondLst>
                                         </p:cTn>
                                         <p:tgtEl>
-                                          <p:sndTgt r:embed="rIdSnd2" name="ding.wav"/>
+                                          <p:sndTgt r:embed="rIdSnd5" name="bell2.wav"/>
                                         </p:tgtEl>
                                       </p:cMediaNode>
                                     </p:audio>
@@ -21304,7 +21304,7 @@
                                           </p:endCondLst>
                                         </p:cTn>
                                         <p:tgtEl>
-                                          <p:sndTgt r:embed="rIdSnd3" name="tick.wav"/>
+                                          <p:sndTgt r:embed="rIdSnd6" name="whoosh.wav"/>
                                         </p:tgtEl>
                                       </p:cMediaNode>
                                     </p:audio>
@@ -21376,7 +21376,7 @@
                                           </p:endCondLst>
                                         </p:cTn>
                                         <p:tgtEl>
-                                          <p:sndTgt r:embed="rIdSnd4" name="win.wav"/>
+                                          <p:sndTgt r:embed="rIdSnd7" name="win.wav"/>
                                         </p:tgtEl>
                                       </p:cMediaNode>
                                     </p:audio>
@@ -22091,7 +22091,7 @@
                                           </p:endCondLst>
                                         </p:cTn>
                                         <p:tgtEl>
-                                          <p:sndTgt r:embed="rIdSnd1" name="pop.wav"/>
+                                          <p:sndTgt r:embed="rIdSnd1" name="pluck1.wav"/>
                                         </p:tgtEl>
                                       </p:cMediaNode>
                                     </p:audio>
@@ -22163,7 +22163,7 @@
                                           </p:endCondLst>
                                         </p:cTn>
                                         <p:tgtEl>
-                                          <p:sndTgt r:embed="rIdSnd2" name="ding.wav"/>
+                                          <p:sndTgt r:embed="rIdSnd2" name="bell1.wav"/>
                                         </p:tgtEl>
                                       </p:cMediaNode>
                                     </p:audio>
@@ -22235,7 +22235,7 @@
                                           </p:endCondLst>
                                         </p:cTn>
                                         <p:tgtEl>
-                                          <p:sndTgt r:embed="rIdSnd3" name="tick.wav"/>
+                                          <p:sndTgt r:embed="rIdSnd3" name="bloop.wav"/>
                                         </p:tgtEl>
                                       </p:cMediaNode>
                                     </p:audio>
@@ -22307,7 +22307,7 @@
                                           </p:endCondLst>
                                         </p:cTn>
                                         <p:tgtEl>
-                                          <p:sndTgt r:embed="rIdSnd1" name="pop.wav"/>
+                                          <p:sndTgt r:embed="rIdSnd4" name="pluck2.wav"/>
                                         </p:tgtEl>
                                       </p:cMediaNode>
                                     </p:audio>
@@ -22379,7 +22379,7 @@
                                           </p:endCondLst>
                                         </p:cTn>
                                         <p:tgtEl>
-                                          <p:sndTgt r:embed="rIdSnd2" name="ding.wav"/>
+                                          <p:sndTgt r:embed="rIdSnd5" name="bell2.wav"/>
                                         </p:tgtEl>
                                       </p:cMediaNode>
                                     </p:audio>
@@ -22451,7 +22451,7 @@
                                           </p:endCondLst>
                                         </p:cTn>
                                         <p:tgtEl>
-                                          <p:sndTgt r:embed="rIdSnd3" name="tick.wav"/>
+                                          <p:sndTgt r:embed="rIdSnd6" name="whoosh.wav"/>
                                         </p:tgtEl>
                                       </p:cMediaNode>
                                     </p:audio>
@@ -22523,7 +22523,7 @@
                                           </p:endCondLst>
                                         </p:cTn>
                                         <p:tgtEl>
-                                          <p:sndTgt r:embed="rIdSnd4" name="win.wav"/>
+                                          <p:sndTgt r:embed="rIdSnd7" name="win.wav"/>
                                         </p:tgtEl>
                                       </p:cMediaNode>
                                     </p:audio>
@@ -23238,7 +23238,7 @@
                                           </p:endCondLst>
                                         </p:cTn>
                                         <p:tgtEl>
-                                          <p:sndTgt r:embed="rIdSnd1" name="pop.wav"/>
+                                          <p:sndTgt r:embed="rIdSnd1" name="pluck1.wav"/>
                                         </p:tgtEl>
                                       </p:cMediaNode>
                                     </p:audio>
@@ -23310,7 +23310,7 @@
                                           </p:endCondLst>
                                         </p:cTn>
                                         <p:tgtEl>
-                                          <p:sndTgt r:embed="rIdSnd2" name="ding.wav"/>
+                                          <p:sndTgt r:embed="rIdSnd2" name="bell1.wav"/>
                                         </p:tgtEl>
                                       </p:cMediaNode>
                                     </p:audio>
@@ -23382,7 +23382,7 @@
                                           </p:endCondLst>
                                         </p:cTn>
                                         <p:tgtEl>
-                                          <p:sndTgt r:embed="rIdSnd3" name="tick.wav"/>
+                                          <p:sndTgt r:embed="rIdSnd3" name="bloop.wav"/>
                                         </p:tgtEl>
                                       </p:cMediaNode>
                                     </p:audio>
@@ -23454,7 +23454,7 @@
                                           </p:endCondLst>
                                         </p:cTn>
                                         <p:tgtEl>
-                                          <p:sndTgt r:embed="rIdSnd1" name="pop.wav"/>
+                                          <p:sndTgt r:embed="rIdSnd4" name="pluck2.wav"/>
                                         </p:tgtEl>
                                       </p:cMediaNode>
                                     </p:audio>
@@ -23526,7 +23526,7 @@
                                           </p:endCondLst>
                                         </p:cTn>
                                         <p:tgtEl>
-                                          <p:sndTgt r:embed="rIdSnd2" name="ding.wav"/>
+                                          <p:sndTgt r:embed="rIdSnd5" name="bell2.wav"/>
                                         </p:tgtEl>
                                       </p:cMediaNode>
                                     </p:audio>
@@ -23598,7 +23598,7 @@
                                           </p:endCondLst>
                                         </p:cTn>
                                         <p:tgtEl>
-                                          <p:sndTgt r:embed="rIdSnd3" name="tick.wav"/>
+                                          <p:sndTgt r:embed="rIdSnd6" name="whoosh.wav"/>
                                         </p:tgtEl>
                                       </p:cMediaNode>
                                     </p:audio>
@@ -23670,7 +23670,7 @@
                                           </p:endCondLst>
                                         </p:cTn>
                                         <p:tgtEl>
-                                          <p:sndTgt r:embed="rIdSnd4" name="win.wav"/>
+                                          <p:sndTgt r:embed="rIdSnd7" name="win.wav"/>
                                         </p:tgtEl>
                                       </p:cMediaNode>
                                     </p:audio>
@@ -24385,7 +24385,7 @@
                                           </p:endCondLst>
                                         </p:cTn>
                                         <p:tgtEl>
-                                          <p:sndTgt r:embed="rIdSnd1" name="pop.wav"/>
+                                          <p:sndTgt r:embed="rIdSnd1" name="pluck1.wav"/>
                                         </p:tgtEl>
                                       </p:cMediaNode>
                                     </p:audio>
@@ -24457,7 +24457,7 @@
                                           </p:endCondLst>
                                         </p:cTn>
                                         <p:tgtEl>
-                                          <p:sndTgt r:embed="rIdSnd2" name="ding.wav"/>
+                                          <p:sndTgt r:embed="rIdSnd2" name="bell1.wav"/>
                                         </p:tgtEl>
                                       </p:cMediaNode>
                                     </p:audio>
@@ -24529,7 +24529,7 @@
                                           </p:endCondLst>
                                         </p:cTn>
                                         <p:tgtEl>
-                                          <p:sndTgt r:embed="rIdSnd3" name="tick.wav"/>
+                                          <p:sndTgt r:embed="rIdSnd3" name="bloop.wav"/>
                                         </p:tgtEl>
                                       </p:cMediaNode>
                                     </p:audio>
@@ -24601,7 +24601,7 @@
                                           </p:endCondLst>
                                         </p:cTn>
                                         <p:tgtEl>
-                                          <p:sndTgt r:embed="rIdSnd1" name="pop.wav"/>
+                                          <p:sndTgt r:embed="rIdSnd4" name="pluck2.wav"/>
                                         </p:tgtEl>
                                       </p:cMediaNode>
                                     </p:audio>
@@ -24673,7 +24673,7 @@
                                           </p:endCondLst>
                                         </p:cTn>
                                         <p:tgtEl>
-                                          <p:sndTgt r:embed="rIdSnd2" name="ding.wav"/>
+                                          <p:sndTgt r:embed="rIdSnd5" name="bell2.wav"/>
                                         </p:tgtEl>
                                       </p:cMediaNode>
                                     </p:audio>
@@ -24745,7 +24745,7 @@
                                           </p:endCondLst>
                                         </p:cTn>
                                         <p:tgtEl>
-                                          <p:sndTgt r:embed="rIdSnd3" name="tick.wav"/>
+                                          <p:sndTgt r:embed="rIdSnd6" name="whoosh.wav"/>
                                         </p:tgtEl>
                                       </p:cMediaNode>
                                     </p:audio>
@@ -24817,7 +24817,7 @@
                                           </p:endCondLst>
                                         </p:cTn>
                                         <p:tgtEl>
-                                          <p:sndTgt r:embed="rIdSnd4" name="win.wav"/>
+                                          <p:sndTgt r:embed="rIdSnd7" name="win.wav"/>
                                         </p:tgtEl>
                                       </p:cMediaNode>
                                     </p:audio>
@@ -25532,7 +25532,7 @@
                                           </p:endCondLst>
                                         </p:cTn>
                                         <p:tgtEl>
-                                          <p:sndTgt r:embed="rIdSnd1" name="pop.wav"/>
+                                          <p:sndTgt r:embed="rIdSnd1" name="pluck1.wav"/>
                                         </p:tgtEl>
                                       </p:cMediaNode>
                                     </p:audio>
@@ -25604,7 +25604,7 @@
                                           </p:endCondLst>
                                         </p:cTn>
                                         <p:tgtEl>
-                                          <p:sndTgt r:embed="rIdSnd2" name="ding.wav"/>
+                                          <p:sndTgt r:embed="rIdSnd2" name="bell1.wav"/>
                                         </p:tgtEl>
                                       </p:cMediaNode>
                                     </p:audio>
@@ -25676,7 +25676,7 @@
                                           </p:endCondLst>
                                         </p:cTn>
                                         <p:tgtEl>
-                                          <p:sndTgt r:embed="rIdSnd3" name="tick.wav"/>
+                                          <p:sndTgt r:embed="rIdSnd3" name="bloop.wav"/>
                                         </p:tgtEl>
                                       </p:cMediaNode>
                                     </p:audio>
@@ -25748,7 +25748,7 @@
                                           </p:endCondLst>
                                         </p:cTn>
                                         <p:tgtEl>
-                                          <p:sndTgt r:embed="rIdSnd1" name="pop.wav"/>
+                                          <p:sndTgt r:embed="rIdSnd4" name="pluck2.wav"/>
                                         </p:tgtEl>
                                       </p:cMediaNode>
                                     </p:audio>
@@ -25820,7 +25820,7 @@
                                           </p:endCondLst>
                                         </p:cTn>
                                         <p:tgtEl>
-                                          <p:sndTgt r:embed="rIdSnd2" name="ding.wav"/>
+                                          <p:sndTgt r:embed="rIdSnd5" name="bell2.wav"/>
                                         </p:tgtEl>
                                       </p:cMediaNode>
                                     </p:audio>
@@ -25892,7 +25892,7 @@
                                           </p:endCondLst>
                                         </p:cTn>
                                         <p:tgtEl>
-                                          <p:sndTgt r:embed="rIdSnd3" name="tick.wav"/>
+                                          <p:sndTgt r:embed="rIdSnd6" name="whoosh.wav"/>
                                         </p:tgtEl>
                                       </p:cMediaNode>
                                     </p:audio>
@@ -25964,7 +25964,7 @@
                                           </p:endCondLst>
                                         </p:cTn>
                                         <p:tgtEl>
-                                          <p:sndTgt r:embed="rIdSnd4" name="win.wav"/>
+                                          <p:sndTgt r:embed="rIdSnd7" name="win.wav"/>
                                         </p:tgtEl>
                                       </p:cMediaNode>
                                     </p:audio>
@@ -26679,7 +26679,7 @@
                                           </p:endCondLst>
                                         </p:cTn>
                                         <p:tgtEl>
-                                          <p:sndTgt r:embed="rIdSnd1" name="pop.wav"/>
+                                          <p:sndTgt r:embed="rIdSnd1" name="pluck1.wav"/>
                                         </p:tgtEl>
                                       </p:cMediaNode>
                                     </p:audio>
@@ -26751,7 +26751,7 @@
                                           </p:endCondLst>
                                         </p:cTn>
                                         <p:tgtEl>
-                                          <p:sndTgt r:embed="rIdSnd2" name="ding.wav"/>
+                                          <p:sndTgt r:embed="rIdSnd2" name="bell1.wav"/>
                                         </p:tgtEl>
                                       </p:cMediaNode>
                                     </p:audio>
@@ -26823,7 +26823,7 @@
                                           </p:endCondLst>
                                         </p:cTn>
                                         <p:tgtEl>
-                                          <p:sndTgt r:embed="rIdSnd3" name="tick.wav"/>
+                                          <p:sndTgt r:embed="rIdSnd3" name="bloop.wav"/>
                                         </p:tgtEl>
                                       </p:cMediaNode>
                                     </p:audio>
@@ -26895,7 +26895,7 @@
                                           </p:endCondLst>
                                         </p:cTn>
                                         <p:tgtEl>
-                                          <p:sndTgt r:embed="rIdSnd1" name="pop.wav"/>
+                                          <p:sndTgt r:embed="rIdSnd4" name="pluck2.wav"/>
                                         </p:tgtEl>
                                       </p:cMediaNode>
                                     </p:audio>
@@ -26967,7 +26967,7 @@
                                           </p:endCondLst>
                                         </p:cTn>
                                         <p:tgtEl>
-                                          <p:sndTgt r:embed="rIdSnd2" name="ding.wav"/>
+                                          <p:sndTgt r:embed="rIdSnd5" name="bell2.wav"/>
                                         </p:tgtEl>
                                       </p:cMediaNode>
                                     </p:audio>
@@ -27039,7 +27039,7 @@
                                           </p:endCondLst>
                                         </p:cTn>
                                         <p:tgtEl>
-                                          <p:sndTgt r:embed="rIdSnd3" name="tick.wav"/>
+                                          <p:sndTgt r:embed="rIdSnd6" name="whoosh.wav"/>
                                         </p:tgtEl>
                                       </p:cMediaNode>
                                     </p:audio>
@@ -27111,7 +27111,7 @@
                                           </p:endCondLst>
                                         </p:cTn>
                                         <p:tgtEl>
-                                          <p:sndTgt r:embed="rIdSnd4" name="win.wav"/>
+                                          <p:sndTgt r:embed="rIdSnd7" name="win.wav"/>
                                         </p:tgtEl>
                                       </p:cMediaNode>
                                     </p:audio>
@@ -27826,7 +27826,7 @@
                                           </p:endCondLst>
                                         </p:cTn>
                                         <p:tgtEl>
-                                          <p:sndTgt r:embed="rIdSnd1" name="pop.wav"/>
+                                          <p:sndTgt r:embed="rIdSnd1" name="pluck1.wav"/>
                                         </p:tgtEl>
                                       </p:cMediaNode>
                                     </p:audio>
@@ -27898,7 +27898,7 @@
                                           </p:endCondLst>
                                         </p:cTn>
                                         <p:tgtEl>
-                                          <p:sndTgt r:embed="rIdSnd2" name="ding.wav"/>
+                                          <p:sndTgt r:embed="rIdSnd2" name="bell1.wav"/>
                                         </p:tgtEl>
                                       </p:cMediaNode>
                                     </p:audio>
@@ -27970,7 +27970,7 @@
                                           </p:endCondLst>
                                         </p:cTn>
                                         <p:tgtEl>
-                                          <p:sndTgt r:embed="rIdSnd3" name="tick.wav"/>
+                                          <p:sndTgt r:embed="rIdSnd3" name="bloop.wav"/>
                                         </p:tgtEl>
                                       </p:cMediaNode>
                                     </p:audio>
@@ -28042,7 +28042,7 @@
                                           </p:endCondLst>
                                         </p:cTn>
                                         <p:tgtEl>
-                                          <p:sndTgt r:embed="rIdSnd1" name="pop.wav"/>
+                                          <p:sndTgt r:embed="rIdSnd4" name="pluck2.wav"/>
                                         </p:tgtEl>
                                       </p:cMediaNode>
                                     </p:audio>
@@ -28114,7 +28114,7 @@
                                           </p:endCondLst>
                                         </p:cTn>
                                         <p:tgtEl>
-                                          <p:sndTgt r:embed="rIdSnd2" name="ding.wav"/>
+                                          <p:sndTgt r:embed="rIdSnd5" name="bell2.wav"/>
                                         </p:tgtEl>
                                       </p:cMediaNode>
                                     </p:audio>
@@ -28186,7 +28186,7 @@
                                           </p:endCondLst>
                                         </p:cTn>
                                         <p:tgtEl>
-                                          <p:sndTgt r:embed="rIdSnd3" name="tick.wav"/>
+                                          <p:sndTgt r:embed="rIdSnd6" name="whoosh.wav"/>
                                         </p:tgtEl>
                                       </p:cMediaNode>
                                     </p:audio>
@@ -28258,7 +28258,7 @@
                                           </p:endCondLst>
                                         </p:cTn>
                                         <p:tgtEl>
-                                          <p:sndTgt r:embed="rIdSnd4" name="win.wav"/>
+                                          <p:sndTgt r:embed="rIdSnd7" name="win.wav"/>
                                         </p:tgtEl>
                                       </p:cMediaNode>
                                     </p:audio>
@@ -29101,7 +29101,7 @@
                                           </p:endCondLst>
                                         </p:cTn>
                                         <p:tgtEl>
-                                          <p:sndTgt r:embed="rIdSnd1" name="pop.wav"/>
+                                          <p:sndTgt r:embed="rIdSnd1" name="pluck1.wav"/>
                                         </p:tgtEl>
                                       </p:cMediaNode>
                                     </p:audio>
@@ -29173,7 +29173,7 @@
                                           </p:endCondLst>
                                         </p:cTn>
                                         <p:tgtEl>
-                                          <p:sndTgt r:embed="rIdSnd2" name="ding.wav"/>
+                                          <p:sndTgt r:embed="rIdSnd2" name="bell1.wav"/>
                                         </p:tgtEl>
                                       </p:cMediaNode>
                                     </p:audio>
@@ -29245,7 +29245,7 @@
                                           </p:endCondLst>
                                         </p:cTn>
                                         <p:tgtEl>
-                                          <p:sndTgt r:embed="rIdSnd3" name="tick.wav"/>
+                                          <p:sndTgt r:embed="rIdSnd3" name="bloop.wav"/>
                                         </p:tgtEl>
                                       </p:cMediaNode>
                                     </p:audio>
@@ -29317,7 +29317,7 @@
                                           </p:endCondLst>
                                         </p:cTn>
                                         <p:tgtEl>
-                                          <p:sndTgt r:embed="rIdSnd1" name="pop.wav"/>
+                                          <p:sndTgt r:embed="rIdSnd4" name="pluck2.wav"/>
                                         </p:tgtEl>
                                       </p:cMediaNode>
                                     </p:audio>
@@ -29389,7 +29389,7 @@
                                           </p:endCondLst>
                                         </p:cTn>
                                         <p:tgtEl>
-                                          <p:sndTgt r:embed="rIdSnd2" name="ding.wav"/>
+                                          <p:sndTgt r:embed="rIdSnd5" name="bell2.wav"/>
                                         </p:tgtEl>
                                       </p:cMediaNode>
                                     </p:audio>
@@ -29461,7 +29461,7 @@
                                           </p:endCondLst>
                                         </p:cTn>
                                         <p:tgtEl>
-                                          <p:sndTgt r:embed="rIdSnd3" name="tick.wav"/>
+                                          <p:sndTgt r:embed="rIdSnd3" name="bloop.wav"/>
                                         </p:tgtEl>
                                       </p:cMediaNode>
                                     </p:audio>
@@ -29533,7 +29533,7 @@
                                           </p:endCondLst>
                                         </p:cTn>
                                         <p:tgtEl>
-                                          <p:sndTgt r:embed="rIdSnd1" name="pop.wav"/>
+                                          <p:sndTgt r:embed="rIdSnd6" name="pluck3.wav"/>
                                         </p:tgtEl>
                                       </p:cMediaNode>
                                     </p:audio>
@@ -29605,7 +29605,7 @@
                                           </p:endCondLst>
                                         </p:cTn>
                                         <p:tgtEl>
-                                          <p:sndTgt r:embed="rIdSnd2" name="ding.wav"/>
+                                          <p:sndTgt r:embed="rIdSnd7" name="bell3.wav"/>
                                         </p:tgtEl>
                                       </p:cMediaNode>
                                     </p:audio>
@@ -29677,7 +29677,7 @@
                                           </p:endCondLst>
                                         </p:cTn>
                                         <p:tgtEl>
-                                          <p:sndTgt r:embed="rIdSnd3" name="tick.wav"/>
+                                          <p:sndTgt r:embed="rIdSnd8" name="whoosh.wav"/>
                                         </p:tgtEl>
                                       </p:cMediaNode>
                                     </p:audio>
@@ -29749,7 +29749,7 @@
                                           </p:endCondLst>
                                         </p:cTn>
                                         <p:tgtEl>
-                                          <p:sndTgt r:embed="rIdSnd4" name="win.wav"/>
+                                          <p:sndTgt r:embed="rIdSnd9" name="win.wav"/>
                                         </p:tgtEl>
                                       </p:cMediaNode>
                                     </p:audio>

</xml_diff>

<commit_message>
Combine every letter with all letters before it in Arabic order (beginning/middle/end) in all four vowel sets
Co-Authored-By: Claude Sonnet 5.5 <noreply@anthropic.com>
Claude-Session: https://claude.ai/code/session_01FzFnzdoj1sJJKm8jQJSfJE
</commit_message>
<xml_diff>
--- a/all-letters-dammah/01-alif.pptx
+++ b/all-letters-dammah/01-alif.pptx
@@ -3923,7 +3923,7 @@
                 <a:ea typeface="Arial" pitchFamily="34" charset="-122"/>
                 <a:cs typeface="Arial" pitchFamily="34" charset="-120"/>
               </a:rPr>
-              <a:t>ب</a:t>
+              <a:t>ث</a:t>
             </a:r>
             <a:endParaRPr lang="ar-SA" sz="6600" dirty="0"/>
           </a:p>
@@ -3962,7 +3962,7 @@
                 <a:ea typeface="Arial" pitchFamily="34" charset="-122"/>
                 <a:cs typeface="Arial" pitchFamily="34" charset="-120"/>
               </a:rPr>
-              <a:t>بُ</a:t>
+              <a:t>ثُ</a:t>
             </a:r>
             <a:endParaRPr lang="ar-SA" sz="6600" dirty="0"/>
           </a:p>
@@ -4001,7 +4001,7 @@
                 <a:ea typeface="Arial" pitchFamily="34" charset="-122"/>
                 <a:cs typeface="Arial" pitchFamily="34" charset="-120"/>
               </a:rPr>
-              <a:t>تُأُبُ</a:t>
+              <a:t>تُأُثُ</a:t>
             </a:r>
             <a:endParaRPr lang="ar-SA" sz="7200" dirty="0"/>
           </a:p>
@@ -5417,7 +5417,7 @@
                 <a:ea typeface="Arial" pitchFamily="34" charset="-122"/>
                 <a:cs typeface="Arial" pitchFamily="34" charset="-120"/>
               </a:rPr>
-              <a:t>ب</a:t>
+              <a:t>ج</a:t>
             </a:r>
             <a:endParaRPr lang="ar-SA" sz="6600" dirty="0"/>
           </a:p>
@@ -5456,7 +5456,7 @@
                 <a:ea typeface="Arial" pitchFamily="34" charset="-122"/>
                 <a:cs typeface="Arial" pitchFamily="34" charset="-120"/>
               </a:rPr>
-              <a:t>بُ</a:t>
+              <a:t>جُ</a:t>
             </a:r>
             <a:endParaRPr lang="ar-SA" sz="6600" dirty="0"/>
           </a:p>
@@ -5495,7 +5495,7 @@
                 <a:ea typeface="Arial" pitchFamily="34" charset="-122"/>
                 <a:cs typeface="Arial" pitchFamily="34" charset="-120"/>
               </a:rPr>
-              <a:t>ثُأُبُ</a:t>
+              <a:t>ثُأُجُ</a:t>
             </a:r>
             <a:endParaRPr lang="ar-SA" sz="7200" dirty="0"/>
           </a:p>
@@ -6911,7 +6911,7 @@
                 <a:ea typeface="Arial" pitchFamily="34" charset="-122"/>
                 <a:cs typeface="Arial" pitchFamily="34" charset="-120"/>
               </a:rPr>
-              <a:t>ب</a:t>
+              <a:t>ح</a:t>
             </a:r>
             <a:endParaRPr lang="ar-SA" sz="6600" dirty="0"/>
           </a:p>
@@ -6950,7 +6950,7 @@
                 <a:ea typeface="Arial" pitchFamily="34" charset="-122"/>
                 <a:cs typeface="Arial" pitchFamily="34" charset="-120"/>
               </a:rPr>
-              <a:t>بُ</a:t>
+              <a:t>حُ</a:t>
             </a:r>
             <a:endParaRPr lang="ar-SA" sz="6600" dirty="0"/>
           </a:p>
@@ -6989,7 +6989,7 @@
                 <a:ea typeface="Arial" pitchFamily="34" charset="-122"/>
                 <a:cs typeface="Arial" pitchFamily="34" charset="-120"/>
               </a:rPr>
-              <a:t>جُأُبُ</a:t>
+              <a:t>جُأُحُ</a:t>
             </a:r>
             <a:endParaRPr lang="ar-SA" sz="7200" dirty="0"/>
           </a:p>
@@ -8405,7 +8405,7 @@
                 <a:ea typeface="Arial" pitchFamily="34" charset="-122"/>
                 <a:cs typeface="Arial" pitchFamily="34" charset="-120"/>
               </a:rPr>
-              <a:t>ب</a:t>
+              <a:t>خ</a:t>
             </a:r>
             <a:endParaRPr lang="ar-SA" sz="6600" dirty="0"/>
           </a:p>
@@ -8444,7 +8444,7 @@
                 <a:ea typeface="Arial" pitchFamily="34" charset="-122"/>
                 <a:cs typeface="Arial" pitchFamily="34" charset="-120"/>
               </a:rPr>
-              <a:t>بُ</a:t>
+              <a:t>خُ</a:t>
             </a:r>
             <a:endParaRPr lang="ar-SA" sz="6600" dirty="0"/>
           </a:p>
@@ -8483,7 +8483,7 @@
                 <a:ea typeface="Arial" pitchFamily="34" charset="-122"/>
                 <a:cs typeface="Arial" pitchFamily="34" charset="-120"/>
               </a:rPr>
-              <a:t>حُأُبُ</a:t>
+              <a:t>حُأُخُ</a:t>
             </a:r>
             <a:endParaRPr lang="ar-SA" sz="7200" dirty="0"/>
           </a:p>
@@ -9899,7 +9899,7 @@
                 <a:ea typeface="Arial" pitchFamily="34" charset="-122"/>
                 <a:cs typeface="Arial" pitchFamily="34" charset="-120"/>
               </a:rPr>
-              <a:t>ب</a:t>
+              <a:t>د</a:t>
             </a:r>
             <a:endParaRPr lang="ar-SA" sz="6600" dirty="0"/>
           </a:p>
@@ -9938,7 +9938,7 @@
                 <a:ea typeface="Arial" pitchFamily="34" charset="-122"/>
                 <a:cs typeface="Arial" pitchFamily="34" charset="-120"/>
               </a:rPr>
-              <a:t>بُ</a:t>
+              <a:t>دُ</a:t>
             </a:r>
             <a:endParaRPr lang="ar-SA" sz="6600" dirty="0"/>
           </a:p>
@@ -9977,7 +9977,7 @@
                 <a:ea typeface="Arial" pitchFamily="34" charset="-122"/>
                 <a:cs typeface="Arial" pitchFamily="34" charset="-120"/>
               </a:rPr>
-              <a:t>خُأُبُ</a:t>
+              <a:t>خُأُدُ</a:t>
             </a:r>
             <a:endParaRPr lang="ar-SA" sz="7200" dirty="0"/>
           </a:p>
@@ -11237,6 +11237,162 @@
                 <a:ea typeface="Arial" pitchFamily="34" charset="-122"/>
                 <a:cs typeface="Arial" pitchFamily="34" charset="-120"/>
               </a:rPr>
+              <a:t>د</a:t>
+            </a:r>
+            <a:endParaRPr lang="ar-SA" sz="6600" dirty="0"/>
+          </a:p>
+        </p:txBody>
+      </p:sp>
+      <p:sp>
+        <p:nvSpPr>
+          <p:cNvPr id="20" name="F1 dammah"/>
+          <p:cNvSpPr txBox="1"/>
+          <p:nvPr/>
+        </p:nvSpPr>
+        <p:spPr>
+          <a:xfrm>
+            <a:off x="7269480" y="1920240"/>
+            <a:ext cx="1280160" cy="1280160"/>
+          </a:xfrm>
+          <a:prstGeom prst="rect">
+            <a:avLst/>
+          </a:prstGeom>
+          <a:noFill/>
+          <a:ln/>
+        </p:spPr>
+        <p:txBody>
+          <a:bodyPr wrap="square" lIns="0" tIns="0" rIns="0" bIns="0" rtlCol="0" anchor="ctr"/>
+          <a:lstStyle/>
+          <a:p>
+            <a:pPr rtl="1" algn="ctr" indent="0" marL="0">
+              <a:buNone/>
+            </a:pPr>
+            <a:r>
+              <a:rPr lang="ar-SA" altLang="en-US" sz="6600" dirty="0">
+                <a:solidFill>
+                  <a:srgbClr val="16213E"/>
+                </a:solidFill>
+                <a:latin typeface="Arial" pitchFamily="34" charset="0"/>
+                <a:ea typeface="Arial" pitchFamily="34" charset="-122"/>
+                <a:cs typeface="Arial" pitchFamily="34" charset="-120"/>
+              </a:rPr>
+              <a:t>دُ</a:t>
+            </a:r>
+            <a:endParaRPr lang="ar-SA" sz="6600" dirty="0"/>
+          </a:p>
+        </p:txBody>
+      </p:sp>
+      <p:sp>
+        <p:nvSpPr>
+          <p:cNvPr id="21" name="L2 letter"/>
+          <p:cNvSpPr txBox="1"/>
+          <p:nvPr/>
+        </p:nvSpPr>
+        <p:spPr>
+          <a:xfrm>
+            <a:off x="5486400" y="1920240"/>
+            <a:ext cx="1280160" cy="1280160"/>
+          </a:xfrm>
+          <a:prstGeom prst="rect">
+            <a:avLst/>
+          </a:prstGeom>
+          <a:noFill/>
+          <a:ln/>
+        </p:spPr>
+        <p:txBody>
+          <a:bodyPr wrap="square" lIns="0" tIns="0" rIns="0" bIns="0" rtlCol="0" anchor="ctr"/>
+          <a:lstStyle/>
+          <a:p>
+            <a:pPr rtl="1" algn="ctr" indent="0" marL="0">
+              <a:buNone/>
+            </a:pPr>
+            <a:r>
+              <a:rPr lang="ar-SA" altLang="en-US" sz="6600" dirty="0">
+                <a:solidFill>
+                  <a:srgbClr val="16213E"/>
+                </a:solidFill>
+                <a:latin typeface="Arial" pitchFamily="34" charset="0"/>
+                <a:ea typeface="Arial" pitchFamily="34" charset="-122"/>
+                <a:cs typeface="Arial" pitchFamily="34" charset="-120"/>
+              </a:rPr>
+              <a:t>أ</a:t>
+            </a:r>
+            <a:endParaRPr lang="ar-SA" sz="6600" dirty="0"/>
+          </a:p>
+        </p:txBody>
+      </p:sp>
+      <p:sp>
+        <p:nvSpPr>
+          <p:cNvPr id="22" name="F2 dammah"/>
+          <p:cNvSpPr txBox="1"/>
+          <p:nvPr/>
+        </p:nvSpPr>
+        <p:spPr>
+          <a:xfrm>
+            <a:off x="5486400" y="1920240"/>
+            <a:ext cx="1280160" cy="1280160"/>
+          </a:xfrm>
+          <a:prstGeom prst="rect">
+            <a:avLst/>
+          </a:prstGeom>
+          <a:noFill/>
+          <a:ln/>
+        </p:spPr>
+        <p:txBody>
+          <a:bodyPr wrap="square" lIns="0" tIns="0" rIns="0" bIns="0" rtlCol="0" anchor="ctr"/>
+          <a:lstStyle/>
+          <a:p>
+            <a:pPr rtl="1" algn="ctr" indent="0" marL="0">
+              <a:buNone/>
+            </a:pPr>
+            <a:r>
+              <a:rPr lang="ar-SA" altLang="en-US" sz="6600" dirty="0">
+                <a:solidFill>
+                  <a:srgbClr val="16213E"/>
+                </a:solidFill>
+                <a:latin typeface="Arial" pitchFamily="34" charset="0"/>
+                <a:ea typeface="Arial" pitchFamily="34" charset="-122"/>
+                <a:cs typeface="Arial" pitchFamily="34" charset="-120"/>
+              </a:rPr>
+              <a:t>أُ</a:t>
+            </a:r>
+            <a:endParaRPr lang="ar-SA" sz="6600" dirty="0"/>
+          </a:p>
+        </p:txBody>
+      </p:sp>
+      <p:sp>
+        <p:nvSpPr>
+          <p:cNvPr id="23" name="L3 letter"/>
+          <p:cNvSpPr txBox="1"/>
+          <p:nvPr/>
+        </p:nvSpPr>
+        <p:spPr>
+          <a:xfrm>
+            <a:off x="3703320" y="1920240"/>
+            <a:ext cx="1280160" cy="1280160"/>
+          </a:xfrm>
+          <a:prstGeom prst="rect">
+            <a:avLst/>
+          </a:prstGeom>
+          <a:noFill/>
+          <a:ln/>
+        </p:spPr>
+        <p:txBody>
+          <a:bodyPr wrap="square" lIns="0" tIns="0" rIns="0" bIns="0" rtlCol="0" anchor="ctr"/>
+          <a:lstStyle/>
+          <a:p>
+            <a:pPr rtl="1" algn="ctr" indent="0" marL="0">
+              <a:buNone/>
+            </a:pPr>
+            <a:r>
+              <a:rPr lang="ar-SA" altLang="en-US" sz="6600" dirty="0">
+                <a:solidFill>
+                  <a:srgbClr val="16213E"/>
+                </a:solidFill>
+                <a:latin typeface="Arial" pitchFamily="34" charset="0"/>
+                <a:ea typeface="Arial" pitchFamily="34" charset="-122"/>
+                <a:cs typeface="Arial" pitchFamily="34" charset="-120"/>
+              </a:rPr>
               <a:t>ب</a:t>
             </a:r>
             <a:endParaRPr lang="ar-SA" sz="6600" dirty="0"/>
@@ -11245,13 +11401,13 @@
       </p:sp>
       <p:sp>
         <p:nvSpPr>
-          <p:cNvPr id="20" name="F1 dammah"/>
+          <p:cNvPr id="24" name="F3 dammah"/>
           <p:cNvSpPr txBox="1"/>
           <p:nvPr/>
         </p:nvSpPr>
         <p:spPr>
           <a:xfrm>
-            <a:off x="7269480" y="1920240"/>
+            <a:off x="3703320" y="1920240"/>
             <a:ext cx="1280160" cy="1280160"/>
           </a:xfrm>
           <a:prstGeom prst="rect">
@@ -11284,162 +11440,6 @@
       </p:sp>
       <p:sp>
         <p:nvSpPr>
-          <p:cNvPr id="21" name="L2 letter"/>
-          <p:cNvSpPr txBox="1"/>
-          <p:nvPr/>
-        </p:nvSpPr>
-        <p:spPr>
-          <a:xfrm>
-            <a:off x="5486400" y="1920240"/>
-            <a:ext cx="1280160" cy="1280160"/>
-          </a:xfrm>
-          <a:prstGeom prst="rect">
-            <a:avLst/>
-          </a:prstGeom>
-          <a:noFill/>
-          <a:ln/>
-        </p:spPr>
-        <p:txBody>
-          <a:bodyPr wrap="square" lIns="0" tIns="0" rIns="0" bIns="0" rtlCol="0" anchor="ctr"/>
-          <a:lstStyle/>
-          <a:p>
-            <a:pPr rtl="1" algn="ctr" indent="0" marL="0">
-              <a:buNone/>
-            </a:pPr>
-            <a:r>
-              <a:rPr lang="ar-SA" altLang="en-US" sz="6600" dirty="0">
-                <a:solidFill>
-                  <a:srgbClr val="16213E"/>
-                </a:solidFill>
-                <a:latin typeface="Arial" pitchFamily="34" charset="0"/>
-                <a:ea typeface="Arial" pitchFamily="34" charset="-122"/>
-                <a:cs typeface="Arial" pitchFamily="34" charset="-120"/>
-              </a:rPr>
-              <a:t>أ</a:t>
-            </a:r>
-            <a:endParaRPr lang="ar-SA" sz="6600" dirty="0"/>
-          </a:p>
-        </p:txBody>
-      </p:sp>
-      <p:sp>
-        <p:nvSpPr>
-          <p:cNvPr id="22" name="F2 dammah"/>
-          <p:cNvSpPr txBox="1"/>
-          <p:nvPr/>
-        </p:nvSpPr>
-        <p:spPr>
-          <a:xfrm>
-            <a:off x="5486400" y="1920240"/>
-            <a:ext cx="1280160" cy="1280160"/>
-          </a:xfrm>
-          <a:prstGeom prst="rect">
-            <a:avLst/>
-          </a:prstGeom>
-          <a:noFill/>
-          <a:ln/>
-        </p:spPr>
-        <p:txBody>
-          <a:bodyPr wrap="square" lIns="0" tIns="0" rIns="0" bIns="0" rtlCol="0" anchor="ctr"/>
-          <a:lstStyle/>
-          <a:p>
-            <a:pPr rtl="1" algn="ctr" indent="0" marL="0">
-              <a:buNone/>
-            </a:pPr>
-            <a:r>
-              <a:rPr lang="ar-SA" altLang="en-US" sz="6600" dirty="0">
-                <a:solidFill>
-                  <a:srgbClr val="16213E"/>
-                </a:solidFill>
-                <a:latin typeface="Arial" pitchFamily="34" charset="0"/>
-                <a:ea typeface="Arial" pitchFamily="34" charset="-122"/>
-                <a:cs typeface="Arial" pitchFamily="34" charset="-120"/>
-              </a:rPr>
-              <a:t>أُ</a:t>
-            </a:r>
-            <a:endParaRPr lang="ar-SA" sz="6600" dirty="0"/>
-          </a:p>
-        </p:txBody>
-      </p:sp>
-      <p:sp>
-        <p:nvSpPr>
-          <p:cNvPr id="23" name="L3 letter"/>
-          <p:cNvSpPr txBox="1"/>
-          <p:nvPr/>
-        </p:nvSpPr>
-        <p:spPr>
-          <a:xfrm>
-            <a:off x="3703320" y="1920240"/>
-            <a:ext cx="1280160" cy="1280160"/>
-          </a:xfrm>
-          <a:prstGeom prst="rect">
-            <a:avLst/>
-          </a:prstGeom>
-          <a:noFill/>
-          <a:ln/>
-        </p:spPr>
-        <p:txBody>
-          <a:bodyPr wrap="square" lIns="0" tIns="0" rIns="0" bIns="0" rtlCol="0" anchor="ctr"/>
-          <a:lstStyle/>
-          <a:p>
-            <a:pPr rtl="1" algn="ctr" indent="0" marL="0">
-              <a:buNone/>
-            </a:pPr>
-            <a:r>
-              <a:rPr lang="ar-SA" altLang="en-US" sz="6600" dirty="0">
-                <a:solidFill>
-                  <a:srgbClr val="16213E"/>
-                </a:solidFill>
-                <a:latin typeface="Arial" pitchFamily="34" charset="0"/>
-                <a:ea typeface="Arial" pitchFamily="34" charset="-122"/>
-                <a:cs typeface="Arial" pitchFamily="34" charset="-120"/>
-              </a:rPr>
-              <a:t>س</a:t>
-            </a:r>
-            <a:endParaRPr lang="ar-SA" sz="6600" dirty="0"/>
-          </a:p>
-        </p:txBody>
-      </p:sp>
-      <p:sp>
-        <p:nvSpPr>
-          <p:cNvPr id="24" name="F3 dammah"/>
-          <p:cNvSpPr txBox="1"/>
-          <p:nvPr/>
-        </p:nvSpPr>
-        <p:spPr>
-          <a:xfrm>
-            <a:off x="3703320" y="1920240"/>
-            <a:ext cx="1280160" cy="1280160"/>
-          </a:xfrm>
-          <a:prstGeom prst="rect">
-            <a:avLst/>
-          </a:prstGeom>
-          <a:noFill/>
-          <a:ln/>
-        </p:spPr>
-        <p:txBody>
-          <a:bodyPr wrap="square" lIns="0" tIns="0" rIns="0" bIns="0" rtlCol="0" anchor="ctr"/>
-          <a:lstStyle/>
-          <a:p>
-            <a:pPr rtl="1" algn="ctr" indent="0" marL="0">
-              <a:buNone/>
-            </a:pPr>
-            <a:r>
-              <a:rPr lang="ar-SA" altLang="en-US" sz="6600" dirty="0">
-                <a:solidFill>
-                  <a:srgbClr val="16213E"/>
-                </a:solidFill>
-                <a:latin typeface="Arial" pitchFamily="34" charset="0"/>
-                <a:ea typeface="Arial" pitchFamily="34" charset="-122"/>
-                <a:cs typeface="Arial" pitchFamily="34" charset="-120"/>
-              </a:rPr>
-              <a:t>سُ</a:t>
-            </a:r>
-            <a:endParaRPr lang="ar-SA" sz="6600" dirty="0"/>
-          </a:p>
-        </p:txBody>
-      </p:sp>
-      <p:sp>
-        <p:nvSpPr>
           <p:cNvPr id="25" name="R result"/>
           <p:cNvSpPr txBox="1"/>
           <p:nvPr/>
@@ -11471,7 +11471,7 @@
                 <a:ea typeface="Arial" pitchFamily="34" charset="-122"/>
                 <a:cs typeface="Arial" pitchFamily="34" charset="-120"/>
               </a:rPr>
-              <a:t>بُأُسُ</a:t>
+              <a:t>دُأُبُ</a:t>
             </a:r>
             <a:endParaRPr lang="ar-SA" sz="7200" dirty="0"/>
           </a:p>
@@ -12681,7 +12681,7 @@
                 <a:ea typeface="Arial" pitchFamily="34" charset="-122"/>
                 <a:cs typeface="Arial" pitchFamily="34" charset="-120"/>
               </a:rPr>
-              <a:t>س</a:t>
+              <a:t>ب</a:t>
             </a:r>
             <a:endParaRPr lang="ar-SA" sz="9000" dirty="0"/>
           </a:p>
@@ -12720,7 +12720,7 @@
                 <a:ea typeface="Arial" pitchFamily="34" charset="-122"/>
                 <a:cs typeface="Arial" pitchFamily="34" charset="-120"/>
               </a:rPr>
-              <a:t>سُ</a:t>
+              <a:t>بُ</a:t>
             </a:r>
             <a:endParaRPr lang="ar-SA" sz="9000" dirty="0"/>
           </a:p>
@@ -12837,7 +12837,7 @@
                 <a:ea typeface="Arial" pitchFamily="34" charset="-122"/>
                 <a:cs typeface="Arial" pitchFamily="34" charset="-120"/>
               </a:rPr>
-              <a:t>سُأُ</a:t>
+              <a:t>بُأُ</a:t>
             </a:r>
             <a:endParaRPr lang="ar-SA" sz="9600" dirty="0"/>
           </a:p>
@@ -13828,7 +13828,7 @@
                 <a:ea typeface="Arial" pitchFamily="34" charset="-122"/>
                 <a:cs typeface="Arial" pitchFamily="34" charset="-120"/>
               </a:rPr>
-              <a:t>ب</a:t>
+              <a:t>ت</a:t>
             </a:r>
             <a:endParaRPr lang="ar-SA" sz="9000" dirty="0"/>
           </a:p>
@@ -13867,7 +13867,7 @@
                 <a:ea typeface="Arial" pitchFamily="34" charset="-122"/>
                 <a:cs typeface="Arial" pitchFamily="34" charset="-120"/>
               </a:rPr>
-              <a:t>بُ</a:t>
+              <a:t>تُ</a:t>
             </a:r>
             <a:endParaRPr lang="ar-SA" sz="9000" dirty="0"/>
           </a:p>
@@ -13984,7 +13984,7 @@
                 <a:ea typeface="Arial" pitchFamily="34" charset="-122"/>
                 <a:cs typeface="Arial" pitchFamily="34" charset="-120"/>
               </a:rPr>
-              <a:t>بُأُ</a:t>
+              <a:t>تُأُ</a:t>
             </a:r>
             <a:endParaRPr lang="ar-SA" sz="9600" dirty="0"/>
           </a:p>
@@ -14975,7 +14975,7 @@
                 <a:ea typeface="Arial" pitchFamily="34" charset="-122"/>
                 <a:cs typeface="Arial" pitchFamily="34" charset="-120"/>
               </a:rPr>
-              <a:t>ت</a:t>
+              <a:t>ث</a:t>
             </a:r>
             <a:endParaRPr lang="ar-SA" sz="9000" dirty="0"/>
           </a:p>
@@ -15014,7 +15014,7 @@
                 <a:ea typeface="Arial" pitchFamily="34" charset="-122"/>
                 <a:cs typeface="Arial" pitchFamily="34" charset="-120"/>
               </a:rPr>
-              <a:t>تُ</a:t>
+              <a:t>ثُ</a:t>
             </a:r>
             <a:endParaRPr lang="ar-SA" sz="9000" dirty="0"/>
           </a:p>
@@ -15131,7 +15131,7 @@
                 <a:ea typeface="Arial" pitchFamily="34" charset="-122"/>
                 <a:cs typeface="Arial" pitchFamily="34" charset="-120"/>
               </a:rPr>
-              <a:t>تُأُ</a:t>
+              <a:t>ثُأُ</a:t>
             </a:r>
             <a:endParaRPr lang="ar-SA" sz="9600" dirty="0"/>
           </a:p>
@@ -16122,7 +16122,7 @@
                 <a:ea typeface="Arial" pitchFamily="34" charset="-122"/>
                 <a:cs typeface="Arial" pitchFamily="34" charset="-120"/>
               </a:rPr>
-              <a:t>ث</a:t>
+              <a:t>ج</a:t>
             </a:r>
             <a:endParaRPr lang="ar-SA" sz="9000" dirty="0"/>
           </a:p>
@@ -16161,7 +16161,7 @@
                 <a:ea typeface="Arial" pitchFamily="34" charset="-122"/>
                 <a:cs typeface="Arial" pitchFamily="34" charset="-120"/>
               </a:rPr>
-              <a:t>ثُ</a:t>
+              <a:t>جُ</a:t>
             </a:r>
             <a:endParaRPr lang="ar-SA" sz="9000" dirty="0"/>
           </a:p>
@@ -16278,7 +16278,7 @@
                 <a:ea typeface="Arial" pitchFamily="34" charset="-122"/>
                 <a:cs typeface="Arial" pitchFamily="34" charset="-120"/>
               </a:rPr>
-              <a:t>ثُأُ</a:t>
+              <a:t>جُأُ</a:t>
             </a:r>
             <a:endParaRPr lang="ar-SA" sz="9600" dirty="0"/>
           </a:p>
@@ -17347,7 +17347,7 @@
                 <a:ea typeface="Arial" pitchFamily="34" charset="-122"/>
                 <a:cs typeface="Arial" pitchFamily="34" charset="-120"/>
               </a:rPr>
-              <a:t>س</a:t>
+              <a:t>ب</a:t>
             </a:r>
             <a:endParaRPr lang="ar-SA" sz="9000" dirty="0"/>
           </a:p>
@@ -17386,7 +17386,7 @@
                 <a:ea typeface="Arial" pitchFamily="34" charset="-122"/>
                 <a:cs typeface="Arial" pitchFamily="34" charset="-120"/>
               </a:rPr>
-              <a:t>سُ</a:t>
+              <a:t>بُ</a:t>
             </a:r>
             <a:endParaRPr lang="ar-SA" sz="9000" dirty="0"/>
           </a:p>
@@ -17425,7 +17425,7 @@
                 <a:ea typeface="Arial" pitchFamily="34" charset="-122"/>
                 <a:cs typeface="Arial" pitchFamily="34" charset="-120"/>
               </a:rPr>
-              <a:t>أُسُ</a:t>
+              <a:t>أُبُ</a:t>
             </a:r>
             <a:endParaRPr lang="ar-SA" sz="9600" dirty="0"/>
           </a:p>
@@ -18416,7 +18416,7 @@
                 <a:ea typeface="Arial" pitchFamily="34" charset="-122"/>
                 <a:cs typeface="Arial" pitchFamily="34" charset="-120"/>
               </a:rPr>
-              <a:t>ج</a:t>
+              <a:t>ح</a:t>
             </a:r>
             <a:endParaRPr lang="ar-SA" sz="9000" dirty="0"/>
           </a:p>
@@ -18455,7 +18455,7 @@
                 <a:ea typeface="Arial" pitchFamily="34" charset="-122"/>
                 <a:cs typeface="Arial" pitchFamily="34" charset="-120"/>
               </a:rPr>
-              <a:t>جُ</a:t>
+              <a:t>حُ</a:t>
             </a:r>
             <a:endParaRPr lang="ar-SA" sz="9000" dirty="0"/>
           </a:p>
@@ -18572,7 +18572,7 @@
                 <a:ea typeface="Arial" pitchFamily="34" charset="-122"/>
                 <a:cs typeface="Arial" pitchFamily="34" charset="-120"/>
               </a:rPr>
-              <a:t>جُأُ</a:t>
+              <a:t>حُأُ</a:t>
             </a:r>
             <a:endParaRPr lang="ar-SA" sz="9600" dirty="0"/>
           </a:p>
@@ -19563,7 +19563,7 @@
                 <a:ea typeface="Arial" pitchFamily="34" charset="-122"/>
                 <a:cs typeface="Arial" pitchFamily="34" charset="-120"/>
               </a:rPr>
-              <a:t>ح</a:t>
+              <a:t>خ</a:t>
             </a:r>
             <a:endParaRPr lang="ar-SA" sz="9000" dirty="0"/>
           </a:p>
@@ -19602,7 +19602,7 @@
                 <a:ea typeface="Arial" pitchFamily="34" charset="-122"/>
                 <a:cs typeface="Arial" pitchFamily="34" charset="-120"/>
               </a:rPr>
-              <a:t>حُ</a:t>
+              <a:t>خُ</a:t>
             </a:r>
             <a:endParaRPr lang="ar-SA" sz="9000" dirty="0"/>
           </a:p>
@@ -19719,7 +19719,7 @@
                 <a:ea typeface="Arial" pitchFamily="34" charset="-122"/>
                 <a:cs typeface="Arial" pitchFamily="34" charset="-120"/>
               </a:rPr>
-              <a:t>حُأُ</a:t>
+              <a:t>خُأُ</a:t>
             </a:r>
             <a:endParaRPr lang="ar-SA" sz="9600" dirty="0"/>
           </a:p>
@@ -20710,7 +20710,7 @@
                 <a:ea typeface="Arial" pitchFamily="34" charset="-122"/>
                 <a:cs typeface="Arial" pitchFamily="34" charset="-120"/>
               </a:rPr>
-              <a:t>خ</a:t>
+              <a:t>د</a:t>
             </a:r>
             <a:endParaRPr lang="ar-SA" sz="9000" dirty="0"/>
           </a:p>
@@ -20749,7 +20749,7 @@
                 <a:ea typeface="Arial" pitchFamily="34" charset="-122"/>
                 <a:cs typeface="Arial" pitchFamily="34" charset="-120"/>
               </a:rPr>
-              <a:t>خُ</a:t>
+              <a:t>دُ</a:t>
             </a:r>
             <a:endParaRPr lang="ar-SA" sz="9000" dirty="0"/>
           </a:p>
@@ -20866,7 +20866,7 @@
                 <a:ea typeface="Arial" pitchFamily="34" charset="-122"/>
                 <a:cs typeface="Arial" pitchFamily="34" charset="-120"/>
               </a:rPr>
-              <a:t>خُأُ</a:t>
+              <a:t>دُأُ</a:t>
             </a:r>
             <a:endParaRPr lang="ar-SA" sz="9600" dirty="0"/>
           </a:p>
@@ -21935,7 +21935,7 @@
                 <a:ea typeface="Arial" pitchFamily="34" charset="-122"/>
                 <a:cs typeface="Arial" pitchFamily="34" charset="-120"/>
               </a:rPr>
-              <a:t>ب</a:t>
+              <a:t>ت</a:t>
             </a:r>
             <a:endParaRPr lang="ar-SA" sz="9000" dirty="0"/>
           </a:p>
@@ -21974,7 +21974,7 @@
                 <a:ea typeface="Arial" pitchFamily="34" charset="-122"/>
                 <a:cs typeface="Arial" pitchFamily="34" charset="-120"/>
               </a:rPr>
-              <a:t>بُ</a:t>
+              <a:t>تُ</a:t>
             </a:r>
             <a:endParaRPr lang="ar-SA" sz="9000" dirty="0"/>
           </a:p>
@@ -22013,7 +22013,7 @@
                 <a:ea typeface="Arial" pitchFamily="34" charset="-122"/>
                 <a:cs typeface="Arial" pitchFamily="34" charset="-120"/>
               </a:rPr>
-              <a:t>أُبُ</a:t>
+              <a:t>أُتُ</a:t>
             </a:r>
             <a:endParaRPr lang="ar-SA" sz="9600" dirty="0"/>
           </a:p>
@@ -23082,7 +23082,7 @@
                 <a:ea typeface="Arial" pitchFamily="34" charset="-122"/>
                 <a:cs typeface="Arial" pitchFamily="34" charset="-120"/>
               </a:rPr>
-              <a:t>ت</a:t>
+              <a:t>ث</a:t>
             </a:r>
             <a:endParaRPr lang="ar-SA" sz="9000" dirty="0"/>
           </a:p>
@@ -23121,7 +23121,7 @@
                 <a:ea typeface="Arial" pitchFamily="34" charset="-122"/>
                 <a:cs typeface="Arial" pitchFamily="34" charset="-120"/>
               </a:rPr>
-              <a:t>تُ</a:t>
+              <a:t>ثُ</a:t>
             </a:r>
             <a:endParaRPr lang="ar-SA" sz="9000" dirty="0"/>
           </a:p>
@@ -23160,7 +23160,7 @@
                 <a:ea typeface="Arial" pitchFamily="34" charset="-122"/>
                 <a:cs typeface="Arial" pitchFamily="34" charset="-120"/>
               </a:rPr>
-              <a:t>أُتُ</a:t>
+              <a:t>أُثُ</a:t>
             </a:r>
             <a:endParaRPr lang="ar-SA" sz="9600" dirty="0"/>
           </a:p>
@@ -24229,7 +24229,7 @@
                 <a:ea typeface="Arial" pitchFamily="34" charset="-122"/>
                 <a:cs typeface="Arial" pitchFamily="34" charset="-120"/>
               </a:rPr>
-              <a:t>ث</a:t>
+              <a:t>ج</a:t>
             </a:r>
             <a:endParaRPr lang="ar-SA" sz="9000" dirty="0"/>
           </a:p>
@@ -24268,7 +24268,7 @@
                 <a:ea typeface="Arial" pitchFamily="34" charset="-122"/>
                 <a:cs typeface="Arial" pitchFamily="34" charset="-120"/>
               </a:rPr>
-              <a:t>ثُ</a:t>
+              <a:t>جُ</a:t>
             </a:r>
             <a:endParaRPr lang="ar-SA" sz="9000" dirty="0"/>
           </a:p>
@@ -24307,7 +24307,7 @@
                 <a:ea typeface="Arial" pitchFamily="34" charset="-122"/>
                 <a:cs typeface="Arial" pitchFamily="34" charset="-120"/>
               </a:rPr>
-              <a:t>أُثُ</a:t>
+              <a:t>أُجُ</a:t>
             </a:r>
             <a:endParaRPr lang="ar-SA" sz="9600" dirty="0"/>
           </a:p>
@@ -25376,7 +25376,7 @@
                 <a:ea typeface="Arial" pitchFamily="34" charset="-122"/>
                 <a:cs typeface="Arial" pitchFamily="34" charset="-120"/>
               </a:rPr>
-              <a:t>ج</a:t>
+              <a:t>ح</a:t>
             </a:r>
             <a:endParaRPr lang="ar-SA" sz="9000" dirty="0"/>
           </a:p>
@@ -25415,7 +25415,7 @@
                 <a:ea typeface="Arial" pitchFamily="34" charset="-122"/>
                 <a:cs typeface="Arial" pitchFamily="34" charset="-120"/>
               </a:rPr>
-              <a:t>جُ</a:t>
+              <a:t>حُ</a:t>
             </a:r>
             <a:endParaRPr lang="ar-SA" sz="9000" dirty="0"/>
           </a:p>
@@ -25454,7 +25454,7 @@
                 <a:ea typeface="Arial" pitchFamily="34" charset="-122"/>
                 <a:cs typeface="Arial" pitchFamily="34" charset="-120"/>
               </a:rPr>
-              <a:t>أُجُ</a:t>
+              <a:t>أُحُ</a:t>
             </a:r>
             <a:endParaRPr lang="ar-SA" sz="9600" dirty="0"/>
           </a:p>
@@ -26523,7 +26523,7 @@
                 <a:ea typeface="Arial" pitchFamily="34" charset="-122"/>
                 <a:cs typeface="Arial" pitchFamily="34" charset="-120"/>
               </a:rPr>
-              <a:t>ح</a:t>
+              <a:t>خ</a:t>
             </a:r>
             <a:endParaRPr lang="ar-SA" sz="9000" dirty="0"/>
           </a:p>
@@ -26562,7 +26562,7 @@
                 <a:ea typeface="Arial" pitchFamily="34" charset="-122"/>
                 <a:cs typeface="Arial" pitchFamily="34" charset="-120"/>
               </a:rPr>
-              <a:t>حُ</a:t>
+              <a:t>خُ</a:t>
             </a:r>
             <a:endParaRPr lang="ar-SA" sz="9000" dirty="0"/>
           </a:p>
@@ -26601,7 +26601,7 @@
                 <a:ea typeface="Arial" pitchFamily="34" charset="-122"/>
                 <a:cs typeface="Arial" pitchFamily="34" charset="-120"/>
               </a:rPr>
-              <a:t>أُحُ</a:t>
+              <a:t>أُخُ</a:t>
             </a:r>
             <a:endParaRPr lang="ar-SA" sz="9600" dirty="0"/>
           </a:p>
@@ -27670,7 +27670,7 @@
                 <a:ea typeface="Arial" pitchFamily="34" charset="-122"/>
                 <a:cs typeface="Arial" pitchFamily="34" charset="-120"/>
               </a:rPr>
-              <a:t>خ</a:t>
+              <a:t>د</a:t>
             </a:r>
             <a:endParaRPr lang="ar-SA" sz="9000" dirty="0"/>
           </a:p>
@@ -27709,7 +27709,7 @@
                 <a:ea typeface="Arial" pitchFamily="34" charset="-122"/>
                 <a:cs typeface="Arial" pitchFamily="34" charset="-120"/>
               </a:rPr>
-              <a:t>خُ</a:t>
+              <a:t>دُ</a:t>
             </a:r>
             <a:endParaRPr lang="ar-SA" sz="9000" dirty="0"/>
           </a:p>
@@ -27748,7 +27748,7 @@
                 <a:ea typeface="Arial" pitchFamily="34" charset="-122"/>
                 <a:cs typeface="Arial" pitchFamily="34" charset="-120"/>
               </a:rPr>
-              <a:t>أُخُ</a:t>
+              <a:t>أُدُ</a:t>
             </a:r>
             <a:endParaRPr lang="ar-SA" sz="9600" dirty="0"/>
           </a:p>

</xml_diff>